<commit_message>
release: V2.0 - Bedarfsanalyse, Mitarbeiter, Hilfe, Report + neues Theme
- Version auf 2.0.0 / 'V2.0' angehoben (backup.py APP_VERSION/DISPLAY,
  version.json, neuer Installer installer/NMGone_Setup_2_0_0.iss)
- Changelog-Eintrag V2.0 fuer die Versionsinfo-Seite
- Praesentation aktualisiert (Stand V2.0, Roadmap, Modul-Umbenennung
  Neue Auswertung -> Bedarfsanalyse) + neu erzeugt
- build_installer.bat zeigt auf das V2.0-Setup

Co-Authored-By: Claude Opus 4.8 <noreply@anthropic.com>
</commit_message>
<xml_diff>
--- a/NMGone_Praesentation_Geschaeftsfuehrung.pptx
+++ b/NMGone_Praesentation_Geschaeftsfuehrung.pptx
@@ -5,20 +5,20 @@
     <p:sldMasterId id="2147483648" r:id="rId1"/>
   </p:sldMasterIdLst>
   <p:sldIdLst>
-    <p:sldId id="256" r:id="rId2"/>
-    <p:sldId id="257" r:id="rId3"/>
-    <p:sldId id="258" r:id="rId4"/>
-    <p:sldId id="259" r:id="rId5"/>
-    <p:sldId id="260" r:id="rId6"/>
-    <p:sldId id="261" r:id="rId7"/>
-    <p:sldId id="262" r:id="rId8"/>
-    <p:sldId id="263" r:id="rId9"/>
-    <p:sldId id="264" r:id="rId10"/>
-    <p:sldId id="265" r:id="rId11"/>
-    <p:sldId id="266" r:id="rId12"/>
-    <p:sldId id="267" r:id="rId13"/>
+    <p:sldId id="256" r:id="rId7"/>
+    <p:sldId id="257" r:id="rId8"/>
+    <p:sldId id="258" r:id="rId9"/>
+    <p:sldId id="259" r:id="rId10"/>
+    <p:sldId id="260" r:id="rId11"/>
+    <p:sldId id="261" r:id="rId12"/>
+    <p:sldId id="262" r:id="rId13"/>
+    <p:sldId id="263" r:id="rId14"/>
+    <p:sldId id="264" r:id="rId15"/>
+    <p:sldId id="265" r:id="rId16"/>
+    <p:sldId id="266" r:id="rId17"/>
+    <p:sldId id="267" r:id="rId18"/>
   </p:sldIdLst>
-  <p:sldSz cx="12192000" cy="6858000"/>
+  <p:sldSz cx="12191695" cy="6858000" type="screen4x3"/>
   <p:notesSz cx="6858000" cy="9144000"/>
   <p:defaultTextStyle>
     <a:defPPr>
@@ -115,22 +115,6 @@
       </a:defRPr>
     </a:lvl9pPr>
   </p:defaultTextStyle>
-  <p:extLst>
-    <p:ext uri="{EFAFB233-063F-42B5-8137-9DF3F51BA10A}">
-      <p15:sldGuideLst xmlns:p15="http://schemas.microsoft.com/office/powerpoint/2012/main">
-        <p15:guide id="1" orient="horz" pos="2160">
-          <p15:clr>
-            <a:srgbClr val="A4A3A4"/>
-          </p15:clr>
-        </p15:guide>
-        <p15:guide id="2" pos="2880">
-          <p15:clr>
-            <a:srgbClr val="A4A3A4"/>
-          </p15:clr>
-        </p15:guide>
-      </p15:sldGuideLst>
-    </p:ext>
-  </p:extLst>
 </p:presentation>
 </file>
 
@@ -172,9 +156,10 @@
           <a:lstStyle/>
           <a:p>
             <a:r>
-              <a:rPr lang="en-US"/>
+              <a:rPr lang="en-US" smtClean="0"/>
               <a:t>Click to edit Master title style</a:t>
             </a:r>
+            <a:endParaRPr lang="en-US"/>
           </a:p>
         </p:txBody>
       </p:sp>
@@ -290,9 +275,10 @@
           </a:lstStyle>
           <a:p>
             <a:r>
-              <a:rPr lang="en-US"/>
+              <a:rPr lang="en-US" smtClean="0"/>
               <a:t>Click to edit Master subtitle style</a:t>
             </a:r>
+            <a:endParaRPr lang="en-US"/>
           </a:p>
         </p:txBody>
       </p:sp>
@@ -313,7 +299,7 @@
           <a:p>
             <a:fld id="{5BCAD085-E8A6-8845-BD4E-CB4CCA059FC4}" type="datetimeFigureOut">
               <a:rPr lang="en-US" smtClean="0"/>
-              <a:t>6/22/2026</a:t>
+              <a:t>1/27/13</a:t>
             </a:fld>
             <a:endParaRPr lang="en-US"/>
           </a:p>
@@ -355,7 +341,7 @@
           <a:p>
             <a:fld id="{C1FF6DA9-008F-8B48-92A6-B652298478BF}" type="slidenum">
               <a:rPr lang="en-US" smtClean="0"/>
-              <a:t>‹Nr.›</a:t>
+              <a:t>‹#›</a:t>
             </a:fld>
             <a:endParaRPr lang="en-US"/>
           </a:p>
@@ -407,9 +393,10 @@
           <a:lstStyle/>
           <a:p>
             <a:r>
-              <a:rPr lang="en-US"/>
+              <a:rPr lang="en-US" smtClean="0"/>
               <a:t>Click to edit Master title style</a:t>
             </a:r>
+            <a:endParaRPr lang="en-US"/>
           </a:p>
         </p:txBody>
       </p:sp>
@@ -430,37 +417,38 @@
           <a:p>
             <a:pPr lvl="0"/>
             <a:r>
-              <a:rPr lang="en-US"/>
+              <a:rPr lang="en-US" smtClean="0"/>
               <a:t>Click to edit Master text styles</a:t>
             </a:r>
           </a:p>
           <a:p>
             <a:pPr lvl="1"/>
             <a:r>
-              <a:rPr lang="en-US"/>
+              <a:rPr lang="en-US" smtClean="0"/>
               <a:t>Second level</a:t>
             </a:r>
           </a:p>
           <a:p>
             <a:pPr lvl="2"/>
             <a:r>
-              <a:rPr lang="en-US"/>
+              <a:rPr lang="en-US" smtClean="0"/>
               <a:t>Third level</a:t>
             </a:r>
           </a:p>
           <a:p>
             <a:pPr lvl="3"/>
             <a:r>
-              <a:rPr lang="en-US"/>
+              <a:rPr lang="en-US" smtClean="0"/>
               <a:t>Fourth level</a:t>
             </a:r>
           </a:p>
           <a:p>
             <a:pPr lvl="4"/>
             <a:r>
-              <a:rPr lang="en-US"/>
+              <a:rPr lang="en-US" smtClean="0"/>
               <a:t>Fifth level</a:t>
             </a:r>
+            <a:endParaRPr lang="en-US"/>
           </a:p>
         </p:txBody>
       </p:sp>
@@ -481,7 +469,7 @@
           <a:p>
             <a:fld id="{5BCAD085-E8A6-8845-BD4E-CB4CCA059FC4}" type="datetimeFigureOut">
               <a:rPr lang="en-US" smtClean="0"/>
-              <a:t>6/22/2026</a:t>
+              <a:t>1/27/13</a:t>
             </a:fld>
             <a:endParaRPr lang="en-US"/>
           </a:p>
@@ -523,7 +511,7 @@
           <a:p>
             <a:fld id="{C1FF6DA9-008F-8B48-92A6-B652298478BF}" type="slidenum">
               <a:rPr lang="en-US" smtClean="0"/>
-              <a:t>‹Nr.›</a:t>
+              <a:t>‹#›</a:t>
             </a:fld>
             <a:endParaRPr lang="en-US"/>
           </a:p>
@@ -580,9 +568,10 @@
           <a:lstStyle/>
           <a:p>
             <a:r>
-              <a:rPr lang="en-US"/>
+              <a:rPr lang="en-US" smtClean="0"/>
               <a:t>Click to edit Master title style</a:t>
             </a:r>
+            <a:endParaRPr lang="en-US"/>
           </a:p>
         </p:txBody>
       </p:sp>
@@ -608,37 +597,38 @@
           <a:p>
             <a:pPr lvl="0"/>
             <a:r>
-              <a:rPr lang="en-US"/>
+              <a:rPr lang="en-US" smtClean="0"/>
               <a:t>Click to edit Master text styles</a:t>
             </a:r>
           </a:p>
           <a:p>
             <a:pPr lvl="1"/>
             <a:r>
-              <a:rPr lang="en-US"/>
+              <a:rPr lang="en-US" smtClean="0"/>
               <a:t>Second level</a:t>
             </a:r>
           </a:p>
           <a:p>
             <a:pPr lvl="2"/>
             <a:r>
-              <a:rPr lang="en-US"/>
+              <a:rPr lang="en-US" smtClean="0"/>
               <a:t>Third level</a:t>
             </a:r>
           </a:p>
           <a:p>
             <a:pPr lvl="3"/>
             <a:r>
-              <a:rPr lang="en-US"/>
+              <a:rPr lang="en-US" smtClean="0"/>
               <a:t>Fourth level</a:t>
             </a:r>
           </a:p>
           <a:p>
             <a:pPr lvl="4"/>
             <a:r>
-              <a:rPr lang="en-US"/>
+              <a:rPr lang="en-US" smtClean="0"/>
               <a:t>Fifth level</a:t>
             </a:r>
+            <a:endParaRPr lang="en-US"/>
           </a:p>
         </p:txBody>
       </p:sp>
@@ -659,7 +649,7 @@
           <a:p>
             <a:fld id="{5BCAD085-E8A6-8845-BD4E-CB4CCA059FC4}" type="datetimeFigureOut">
               <a:rPr lang="en-US" smtClean="0"/>
-              <a:t>6/22/2026</a:t>
+              <a:t>1/27/13</a:t>
             </a:fld>
             <a:endParaRPr lang="en-US"/>
           </a:p>
@@ -701,7 +691,7 @@
           <a:p>
             <a:fld id="{C1FF6DA9-008F-8B48-92A6-B652298478BF}" type="slidenum">
               <a:rPr lang="en-US" smtClean="0"/>
-              <a:t>‹Nr.›</a:t>
+              <a:t>‹#›</a:t>
             </a:fld>
             <a:endParaRPr lang="en-US"/>
           </a:p>
@@ -753,9 +743,10 @@
           <a:lstStyle/>
           <a:p>
             <a:r>
-              <a:rPr lang="en-US"/>
+              <a:rPr lang="en-US" smtClean="0"/>
               <a:t>Click to edit Master title style</a:t>
             </a:r>
+            <a:endParaRPr lang="en-US"/>
           </a:p>
         </p:txBody>
       </p:sp>
@@ -776,37 +767,38 @@
           <a:p>
             <a:pPr lvl="0"/>
             <a:r>
-              <a:rPr lang="en-US"/>
+              <a:rPr lang="en-US" smtClean="0"/>
               <a:t>Click to edit Master text styles</a:t>
             </a:r>
           </a:p>
           <a:p>
             <a:pPr lvl="1"/>
             <a:r>
-              <a:rPr lang="en-US"/>
+              <a:rPr lang="en-US" smtClean="0"/>
               <a:t>Second level</a:t>
             </a:r>
           </a:p>
           <a:p>
             <a:pPr lvl="2"/>
             <a:r>
-              <a:rPr lang="en-US"/>
+              <a:rPr lang="en-US" smtClean="0"/>
               <a:t>Third level</a:t>
             </a:r>
           </a:p>
           <a:p>
             <a:pPr lvl="3"/>
             <a:r>
-              <a:rPr lang="en-US"/>
+              <a:rPr lang="en-US" smtClean="0"/>
               <a:t>Fourth level</a:t>
             </a:r>
           </a:p>
           <a:p>
             <a:pPr lvl="4"/>
             <a:r>
-              <a:rPr lang="en-US"/>
+              <a:rPr lang="en-US" smtClean="0"/>
               <a:t>Fifth level</a:t>
             </a:r>
+            <a:endParaRPr lang="en-US"/>
           </a:p>
         </p:txBody>
       </p:sp>
@@ -827,7 +819,7 @@
           <a:p>
             <a:fld id="{5BCAD085-E8A6-8845-BD4E-CB4CCA059FC4}" type="datetimeFigureOut">
               <a:rPr lang="en-US" smtClean="0"/>
-              <a:t>6/22/2026</a:t>
+              <a:t>1/27/13</a:t>
             </a:fld>
             <a:endParaRPr lang="en-US"/>
           </a:p>
@@ -869,7 +861,7 @@
           <a:p>
             <a:fld id="{C1FF6DA9-008F-8B48-92A6-B652298478BF}" type="slidenum">
               <a:rPr lang="en-US" smtClean="0"/>
-              <a:t>‹Nr.›</a:t>
+              <a:t>‹#›</a:t>
             </a:fld>
             <a:endParaRPr lang="en-US"/>
           </a:p>
@@ -930,9 +922,10 @@
           </a:lstStyle>
           <a:p>
             <a:r>
-              <a:rPr lang="en-US"/>
+              <a:rPr lang="en-US" smtClean="0"/>
               <a:t>Click to edit Master title style</a:t>
             </a:r>
+            <a:endParaRPr lang="en-US"/>
           </a:p>
         </p:txBody>
       </p:sp>
@@ -1049,7 +1042,7 @@
           <a:p>
             <a:pPr lvl="0"/>
             <a:r>
-              <a:rPr lang="en-US"/>
+              <a:rPr lang="en-US" smtClean="0"/>
               <a:t>Click to edit Master text styles</a:t>
             </a:r>
           </a:p>
@@ -1072,7 +1065,7 @@
           <a:p>
             <a:fld id="{5BCAD085-E8A6-8845-BD4E-CB4CCA059FC4}" type="datetimeFigureOut">
               <a:rPr lang="en-US" smtClean="0"/>
-              <a:t>6/22/2026</a:t>
+              <a:t>1/27/13</a:t>
             </a:fld>
             <a:endParaRPr lang="en-US"/>
           </a:p>
@@ -1114,7 +1107,7 @@
           <a:p>
             <a:fld id="{C1FF6DA9-008F-8B48-92A6-B652298478BF}" type="slidenum">
               <a:rPr lang="en-US" smtClean="0"/>
-              <a:t>‹Nr.›</a:t>
+              <a:t>‹#›</a:t>
             </a:fld>
             <a:endParaRPr lang="en-US"/>
           </a:p>
@@ -1166,9 +1159,10 @@
           <a:lstStyle/>
           <a:p>
             <a:r>
-              <a:rPr lang="en-US"/>
+              <a:rPr lang="en-US" smtClean="0"/>
               <a:t>Click to edit Master title style</a:t>
             </a:r>
+            <a:endParaRPr lang="en-US"/>
           </a:p>
         </p:txBody>
       </p:sp>
@@ -1222,37 +1216,38 @@
           <a:p>
             <a:pPr lvl="0"/>
             <a:r>
-              <a:rPr lang="en-US"/>
+              <a:rPr lang="en-US" smtClean="0"/>
               <a:t>Click to edit Master text styles</a:t>
             </a:r>
           </a:p>
           <a:p>
             <a:pPr lvl="1"/>
             <a:r>
-              <a:rPr lang="en-US"/>
+              <a:rPr lang="en-US" smtClean="0"/>
               <a:t>Second level</a:t>
             </a:r>
           </a:p>
           <a:p>
             <a:pPr lvl="2"/>
             <a:r>
-              <a:rPr lang="en-US"/>
+              <a:rPr lang="en-US" smtClean="0"/>
               <a:t>Third level</a:t>
             </a:r>
           </a:p>
           <a:p>
             <a:pPr lvl="3"/>
             <a:r>
-              <a:rPr lang="en-US"/>
+              <a:rPr lang="en-US" smtClean="0"/>
               <a:t>Fourth level</a:t>
             </a:r>
           </a:p>
           <a:p>
             <a:pPr lvl="4"/>
             <a:r>
-              <a:rPr lang="en-US"/>
+              <a:rPr lang="en-US" smtClean="0"/>
               <a:t>Fifth level</a:t>
             </a:r>
+            <a:endParaRPr lang="en-US"/>
           </a:p>
         </p:txBody>
       </p:sp>
@@ -1306,37 +1301,38 @@
           <a:p>
             <a:pPr lvl="0"/>
             <a:r>
-              <a:rPr lang="en-US"/>
+              <a:rPr lang="en-US" smtClean="0"/>
               <a:t>Click to edit Master text styles</a:t>
             </a:r>
           </a:p>
           <a:p>
             <a:pPr lvl="1"/>
             <a:r>
-              <a:rPr lang="en-US"/>
+              <a:rPr lang="en-US" smtClean="0"/>
               <a:t>Second level</a:t>
             </a:r>
           </a:p>
           <a:p>
             <a:pPr lvl="2"/>
             <a:r>
-              <a:rPr lang="en-US"/>
+              <a:rPr lang="en-US" smtClean="0"/>
               <a:t>Third level</a:t>
             </a:r>
           </a:p>
           <a:p>
             <a:pPr lvl="3"/>
             <a:r>
-              <a:rPr lang="en-US"/>
+              <a:rPr lang="en-US" smtClean="0"/>
               <a:t>Fourth level</a:t>
             </a:r>
           </a:p>
           <a:p>
             <a:pPr lvl="4"/>
             <a:r>
-              <a:rPr lang="en-US"/>
+              <a:rPr lang="en-US" smtClean="0"/>
               <a:t>Fifth level</a:t>
             </a:r>
+            <a:endParaRPr lang="en-US"/>
           </a:p>
         </p:txBody>
       </p:sp>
@@ -1357,7 +1353,7 @@
           <a:p>
             <a:fld id="{5BCAD085-E8A6-8845-BD4E-CB4CCA059FC4}" type="datetimeFigureOut">
               <a:rPr lang="en-US" smtClean="0"/>
-              <a:t>6/22/2026</a:t>
+              <a:t>1/27/13</a:t>
             </a:fld>
             <a:endParaRPr lang="en-US"/>
           </a:p>
@@ -1399,7 +1395,7 @@
           <a:p>
             <a:fld id="{C1FF6DA9-008F-8B48-92A6-B652298478BF}" type="slidenum">
               <a:rPr lang="en-US" smtClean="0"/>
-              <a:t>‹Nr.›</a:t>
+              <a:t>‹#›</a:t>
             </a:fld>
             <a:endParaRPr lang="en-US"/>
           </a:p>
@@ -1455,9 +1451,10 @@
           </a:lstStyle>
           <a:p>
             <a:r>
-              <a:rPr lang="en-US"/>
+              <a:rPr lang="en-US" smtClean="0"/>
               <a:t>Click to edit Master title style</a:t>
             </a:r>
+            <a:endParaRPr lang="en-US"/>
           </a:p>
         </p:txBody>
       </p:sp>
@@ -1520,7 +1517,7 @@
           <a:p>
             <a:pPr lvl="0"/>
             <a:r>
-              <a:rPr lang="en-US"/>
+              <a:rPr lang="en-US" smtClean="0"/>
               <a:t>Click to edit Master text styles</a:t>
             </a:r>
           </a:p>
@@ -1576,37 +1573,38 @@
           <a:p>
             <a:pPr lvl="0"/>
             <a:r>
-              <a:rPr lang="en-US"/>
+              <a:rPr lang="en-US" smtClean="0"/>
               <a:t>Click to edit Master text styles</a:t>
             </a:r>
           </a:p>
           <a:p>
             <a:pPr lvl="1"/>
             <a:r>
-              <a:rPr lang="en-US"/>
+              <a:rPr lang="en-US" smtClean="0"/>
               <a:t>Second level</a:t>
             </a:r>
           </a:p>
           <a:p>
             <a:pPr lvl="2"/>
             <a:r>
-              <a:rPr lang="en-US"/>
+              <a:rPr lang="en-US" smtClean="0"/>
               <a:t>Third level</a:t>
             </a:r>
           </a:p>
           <a:p>
             <a:pPr lvl="3"/>
             <a:r>
-              <a:rPr lang="en-US"/>
+              <a:rPr lang="en-US" smtClean="0"/>
               <a:t>Fourth level</a:t>
             </a:r>
           </a:p>
           <a:p>
             <a:pPr lvl="4"/>
             <a:r>
-              <a:rPr lang="en-US"/>
+              <a:rPr lang="en-US" smtClean="0"/>
               <a:t>Fifth level</a:t>
             </a:r>
+            <a:endParaRPr lang="en-US"/>
           </a:p>
         </p:txBody>
       </p:sp>
@@ -1669,7 +1667,7 @@
           <a:p>
             <a:pPr lvl="0"/>
             <a:r>
-              <a:rPr lang="en-US"/>
+              <a:rPr lang="en-US" smtClean="0"/>
               <a:t>Click to edit Master text styles</a:t>
             </a:r>
           </a:p>
@@ -1725,37 +1723,38 @@
           <a:p>
             <a:pPr lvl="0"/>
             <a:r>
-              <a:rPr lang="en-US"/>
+              <a:rPr lang="en-US" smtClean="0"/>
               <a:t>Click to edit Master text styles</a:t>
             </a:r>
           </a:p>
           <a:p>
             <a:pPr lvl="1"/>
             <a:r>
-              <a:rPr lang="en-US"/>
+              <a:rPr lang="en-US" smtClean="0"/>
               <a:t>Second level</a:t>
             </a:r>
           </a:p>
           <a:p>
             <a:pPr lvl="2"/>
             <a:r>
-              <a:rPr lang="en-US"/>
+              <a:rPr lang="en-US" smtClean="0"/>
               <a:t>Third level</a:t>
             </a:r>
           </a:p>
           <a:p>
             <a:pPr lvl="3"/>
             <a:r>
-              <a:rPr lang="en-US"/>
+              <a:rPr lang="en-US" smtClean="0"/>
               <a:t>Fourth level</a:t>
             </a:r>
           </a:p>
           <a:p>
             <a:pPr lvl="4"/>
             <a:r>
-              <a:rPr lang="en-US"/>
+              <a:rPr lang="en-US" smtClean="0"/>
               <a:t>Fifth level</a:t>
             </a:r>
+            <a:endParaRPr lang="en-US"/>
           </a:p>
         </p:txBody>
       </p:sp>
@@ -1776,7 +1775,7 @@
           <a:p>
             <a:fld id="{5BCAD085-E8A6-8845-BD4E-CB4CCA059FC4}" type="datetimeFigureOut">
               <a:rPr lang="en-US" smtClean="0"/>
-              <a:t>6/22/2026</a:t>
+              <a:t>1/27/13</a:t>
             </a:fld>
             <a:endParaRPr lang="en-US"/>
           </a:p>
@@ -1818,7 +1817,7 @@
           <a:p>
             <a:fld id="{C1FF6DA9-008F-8B48-92A6-B652298478BF}" type="slidenum">
               <a:rPr lang="en-US" smtClean="0"/>
-              <a:t>‹Nr.›</a:t>
+              <a:t>‹#›</a:t>
             </a:fld>
             <a:endParaRPr lang="en-US"/>
           </a:p>
@@ -1870,9 +1869,10 @@
           <a:lstStyle/>
           <a:p>
             <a:r>
-              <a:rPr lang="en-US"/>
+              <a:rPr lang="en-US" smtClean="0"/>
               <a:t>Click to edit Master title style</a:t>
             </a:r>
+            <a:endParaRPr lang="en-US"/>
           </a:p>
         </p:txBody>
       </p:sp>
@@ -1893,7 +1893,7 @@
           <a:p>
             <a:fld id="{5BCAD085-E8A6-8845-BD4E-CB4CCA059FC4}" type="datetimeFigureOut">
               <a:rPr lang="en-US" smtClean="0"/>
-              <a:t>6/22/2026</a:t>
+              <a:t>1/27/13</a:t>
             </a:fld>
             <a:endParaRPr lang="en-US"/>
           </a:p>
@@ -1935,7 +1935,7 @@
           <a:p>
             <a:fld id="{C1FF6DA9-008F-8B48-92A6-B652298478BF}" type="slidenum">
               <a:rPr lang="en-US" smtClean="0"/>
-              <a:t>‹Nr.›</a:t>
+              <a:t>‹#›</a:t>
             </a:fld>
             <a:endParaRPr lang="en-US"/>
           </a:p>
@@ -1988,7 +1988,7 @@
           <a:p>
             <a:fld id="{5BCAD085-E8A6-8845-BD4E-CB4CCA059FC4}" type="datetimeFigureOut">
               <a:rPr lang="en-US" smtClean="0"/>
-              <a:t>6/22/2026</a:t>
+              <a:t>1/27/13</a:t>
             </a:fld>
             <a:endParaRPr lang="en-US"/>
           </a:p>
@@ -2030,7 +2030,7 @@
           <a:p>
             <a:fld id="{C1FF6DA9-008F-8B48-92A6-B652298478BF}" type="slidenum">
               <a:rPr lang="en-US" smtClean="0"/>
-              <a:t>‹Nr.›</a:t>
+              <a:t>‹#›</a:t>
             </a:fld>
             <a:endParaRPr lang="en-US"/>
           </a:p>
@@ -2091,9 +2091,10 @@
           </a:lstStyle>
           <a:p>
             <a:r>
-              <a:rPr lang="en-US"/>
+              <a:rPr lang="en-US" smtClean="0"/>
               <a:t>Click to edit Master title style</a:t>
             </a:r>
+            <a:endParaRPr lang="en-US"/>
           </a:p>
         </p:txBody>
       </p:sp>
@@ -2147,37 +2148,38 @@
           <a:p>
             <a:pPr lvl="0"/>
             <a:r>
-              <a:rPr lang="en-US"/>
+              <a:rPr lang="en-US" smtClean="0"/>
               <a:t>Click to edit Master text styles</a:t>
             </a:r>
           </a:p>
           <a:p>
             <a:pPr lvl="1"/>
             <a:r>
-              <a:rPr lang="en-US"/>
+              <a:rPr lang="en-US" smtClean="0"/>
               <a:t>Second level</a:t>
             </a:r>
           </a:p>
           <a:p>
             <a:pPr lvl="2"/>
             <a:r>
-              <a:rPr lang="en-US"/>
+              <a:rPr lang="en-US" smtClean="0"/>
               <a:t>Third level</a:t>
             </a:r>
           </a:p>
           <a:p>
             <a:pPr lvl="3"/>
             <a:r>
-              <a:rPr lang="en-US"/>
+              <a:rPr lang="en-US" smtClean="0"/>
               <a:t>Fourth level</a:t>
             </a:r>
           </a:p>
           <a:p>
             <a:pPr lvl="4"/>
             <a:r>
-              <a:rPr lang="en-US"/>
+              <a:rPr lang="en-US" smtClean="0"/>
               <a:t>Fifth level</a:t>
             </a:r>
+            <a:endParaRPr lang="en-US"/>
           </a:p>
         </p:txBody>
       </p:sp>
@@ -2240,7 +2242,7 @@
           <a:p>
             <a:pPr lvl="0"/>
             <a:r>
-              <a:rPr lang="en-US"/>
+              <a:rPr lang="en-US" smtClean="0"/>
               <a:t>Click to edit Master text styles</a:t>
             </a:r>
           </a:p>
@@ -2263,7 +2265,7 @@
           <a:p>
             <a:fld id="{5BCAD085-E8A6-8845-BD4E-CB4CCA059FC4}" type="datetimeFigureOut">
               <a:rPr lang="en-US" smtClean="0"/>
-              <a:t>6/22/2026</a:t>
+              <a:t>1/27/13</a:t>
             </a:fld>
             <a:endParaRPr lang="en-US"/>
           </a:p>
@@ -2305,7 +2307,7 @@
           <a:p>
             <a:fld id="{C1FF6DA9-008F-8B48-92A6-B652298478BF}" type="slidenum">
               <a:rPr lang="en-US" smtClean="0"/>
-              <a:t>‹Nr.›</a:t>
+              <a:t>‹#›</a:t>
             </a:fld>
             <a:endParaRPr lang="en-US"/>
           </a:p>
@@ -2366,9 +2368,10 @@
           </a:lstStyle>
           <a:p>
             <a:r>
-              <a:rPr lang="en-US"/>
+              <a:rPr lang="en-US" smtClean="0"/>
               <a:t>Click to edit Master title style</a:t>
             </a:r>
+            <a:endParaRPr lang="en-US"/>
           </a:p>
         </p:txBody>
       </p:sp>
@@ -2492,7 +2495,7 @@
           <a:p>
             <a:pPr lvl="0"/>
             <a:r>
-              <a:rPr lang="en-US"/>
+              <a:rPr lang="en-US" smtClean="0"/>
               <a:t>Click to edit Master text styles</a:t>
             </a:r>
           </a:p>
@@ -2515,7 +2518,7 @@
           <a:p>
             <a:fld id="{5BCAD085-E8A6-8845-BD4E-CB4CCA059FC4}" type="datetimeFigureOut">
               <a:rPr lang="en-US" smtClean="0"/>
-              <a:t>6/22/2026</a:t>
+              <a:t>1/27/13</a:t>
             </a:fld>
             <a:endParaRPr lang="en-US"/>
           </a:p>
@@ -2557,7 +2560,7 @@
           <a:p>
             <a:fld id="{C1FF6DA9-008F-8B48-92A6-B652298478BF}" type="slidenum">
               <a:rPr lang="en-US" smtClean="0"/>
-              <a:t>‹Nr.›</a:t>
+              <a:t>‹#›</a:t>
             </a:fld>
             <a:endParaRPr lang="en-US"/>
           </a:p>
@@ -2624,9 +2627,10 @@
           <a:lstStyle/>
           <a:p>
             <a:r>
-              <a:rPr lang="en-US"/>
+              <a:rPr lang="en-US" smtClean="0"/>
               <a:t>Click to edit Master title style</a:t>
             </a:r>
+            <a:endParaRPr lang="en-US"/>
           </a:p>
         </p:txBody>
       </p:sp>
@@ -2657,37 +2661,38 @@
           <a:p>
             <a:pPr lvl="0"/>
             <a:r>
-              <a:rPr lang="en-US"/>
+              <a:rPr lang="en-US" smtClean="0"/>
               <a:t>Click to edit Master text styles</a:t>
             </a:r>
           </a:p>
           <a:p>
             <a:pPr lvl="1"/>
             <a:r>
-              <a:rPr lang="en-US"/>
+              <a:rPr lang="en-US" smtClean="0"/>
               <a:t>Second level</a:t>
             </a:r>
           </a:p>
           <a:p>
             <a:pPr lvl="2"/>
             <a:r>
-              <a:rPr lang="en-US"/>
+              <a:rPr lang="en-US" smtClean="0"/>
               <a:t>Third level</a:t>
             </a:r>
           </a:p>
           <a:p>
             <a:pPr lvl="3"/>
             <a:r>
-              <a:rPr lang="en-US"/>
+              <a:rPr lang="en-US" smtClean="0"/>
               <a:t>Fourth level</a:t>
             </a:r>
           </a:p>
           <a:p>
             <a:pPr lvl="4"/>
             <a:r>
-              <a:rPr lang="en-US"/>
+              <a:rPr lang="en-US" smtClean="0"/>
               <a:t>Fifth level</a:t>
             </a:r>
+            <a:endParaRPr lang="en-US"/>
           </a:p>
         </p:txBody>
       </p:sp>
@@ -2726,7 +2731,7 @@
           <a:p>
             <a:fld id="{5BCAD085-E8A6-8845-BD4E-CB4CCA059FC4}" type="datetimeFigureOut">
               <a:rPr lang="en-US" smtClean="0"/>
-              <a:t>6/22/2026</a:t>
+              <a:t>1/27/13</a:t>
             </a:fld>
             <a:endParaRPr lang="en-US"/>
           </a:p>
@@ -2804,7 +2809,7 @@
           <a:p>
             <a:fld id="{C1FF6DA9-008F-8B48-92A6-B652298478BF}" type="slidenum">
               <a:rPr lang="en-US" smtClean="0"/>
-              <a:t>‹Nr.›</a:t>
+              <a:t>‹#›</a:t>
             </a:fld>
             <a:endParaRPr lang="en-US"/>
           </a:p>
@@ -3085,7 +3090,7 @@
 </file>
 
 <file path=ppt/slides/slide1.xml><?xml version="1.0" encoding="utf-8"?>
-<p:sld xmlns:a="http://schemas.openxmlformats.org/drawingml/2006/main" xmlns:r="http://schemas.openxmlformats.org/officeDocument/2006/relationships" xmlns:p="http://schemas.openxmlformats.org/presentationml/2006/main">
+<p:sld xmlns:a="http://schemas.openxmlformats.org/drawingml/2006/main" xmlns:p="http://schemas.openxmlformats.org/presentationml/2006/main" xmlns:r="http://schemas.openxmlformats.org/officeDocument/2006/relationships">
   <p:cSld>
     <p:bg>
       <p:bgPr>
@@ -3101,14 +3106,7 @@
         <p:cNvGrpSpPr/>
         <p:nvPr/>
       </p:nvGrpSpPr>
-      <p:grpSpPr>
-        <a:xfrm>
-          <a:off x="0" y="0"/>
-          <a:ext cx="0" cy="0"/>
-          <a:chOff x="0" y="0"/>
-          <a:chExt cx="0" cy="0"/>
-        </a:xfrm>
-      </p:grpSpPr>
+      <p:grpSpPr/>
       <p:sp>
         <p:nvSpPr>
           <p:cNvPr id="2" name="Rectangle 1"/>
@@ -3150,7 +3148,6 @@
           <a:lstStyle/>
           <a:p>
             <a:pPr algn="ctr"/>
-            <a:endParaRPr/>
           </a:p>
         </p:txBody>
       </p:sp>
@@ -3203,7 +3200,6 @@
           <a:lstStyle/>
           <a:p>
             <a:pPr algn="ctr"/>
-            <a:endParaRPr/>
           </a:p>
         </p:txBody>
       </p:sp>
@@ -3274,7 +3270,6 @@
           <a:lstStyle/>
           <a:p>
             <a:pPr algn="ctr"/>
-            <a:endParaRPr/>
           </a:p>
         </p:txBody>
       </p:sp>
@@ -3321,7 +3316,6 @@
           <a:lstStyle/>
           <a:p>
             <a:pPr algn="ctr"/>
-            <a:endParaRPr/>
           </a:p>
         </p:txBody>
       </p:sp>
@@ -3368,7 +3362,6 @@
           <a:lstStyle/>
           <a:p>
             <a:pPr algn="ctr"/>
-            <a:endParaRPr/>
           </a:p>
         </p:txBody>
       </p:sp>
@@ -3415,7 +3408,6 @@
           <a:lstStyle/>
           <a:p>
             <a:pPr algn="ctr"/>
-            <a:endParaRPr/>
           </a:p>
         </p:txBody>
       </p:sp>
@@ -3462,7 +3454,6 @@
           <a:lstStyle/>
           <a:p>
             <a:pPr algn="ctr"/>
-            <a:endParaRPr/>
           </a:p>
         </p:txBody>
       </p:sp>
@@ -3483,7 +3474,7 @@
           <a:noFill/>
         </p:spPr>
         <p:txBody>
-          <a:bodyPr wrap="square" lIns="0" tIns="0" rIns="0" bIns="0" anchor="t">
+          <a:bodyPr wrap="square" anchor="t" lIns="0" rIns="0" tIns="0" bIns="0">
             <a:spAutoFit/>
           </a:bodyPr>
           <a:lstStyle/>
@@ -3574,7 +3565,6 @@
           <a:lstStyle/>
           <a:p>
             <a:pPr algn="ctr"/>
-            <a:endParaRPr/>
           </a:p>
         </p:txBody>
       </p:sp>
@@ -3587,7 +3577,7 @@
         <p:spPr>
           <a:xfrm>
             <a:off x="914400" y="5166360"/>
-            <a:ext cx="10332720" cy="246221"/>
+            <a:ext cx="10332720" cy="1097280"/>
           </a:xfrm>
           <a:prstGeom prst="rect">
             <a:avLst/>
@@ -3595,7 +3585,7 @@
           <a:noFill/>
         </p:spPr>
         <p:txBody>
-          <a:bodyPr wrap="square" lIns="0" tIns="0" rIns="0" bIns="0" anchor="t">
+          <a:bodyPr wrap="square" anchor="t" lIns="0" rIns="0" tIns="0" bIns="0">
             <a:spAutoFit/>
           </a:bodyPr>
           <a:lstStyle/>
@@ -3612,40 +3602,35 @@
               </a:spcAft>
             </a:pPr>
             <a:r>
-              <a:rPr sz="1600" b="1" i="0" dirty="0" err="1">
+              <a:rPr sz="1600" b="1" i="0">
                 <a:solidFill>
                   <a:srgbClr val="B9CDE8"/>
                 </a:solidFill>
                 <a:latin typeface="Calibri"/>
               </a:rPr>
-              <a:t>Eigenentwicklung</a:t>
-            </a:r>
-            <a:r>
-              <a:rPr sz="1600" b="1" i="0" dirty="0">
-                <a:solidFill>
-                  <a:srgbClr val="B9CDE8"/>
+              <a:t>Eigenentwicklung  ·  Stand V2.0  ·  Juni 2026</a:t>
+            </a:r>
+          </a:p>
+          <a:p>
+            <a:pPr algn="l">
+              <a:lnSpc>
+                <a:spcPct val="100000"/>
+              </a:lnSpc>
+              <a:spcBef>
+                <a:spcPts val="0"/>
+              </a:spcBef>
+              <a:spcAft>
+                <a:spcPts val="400"/>
+              </a:spcAft>
+            </a:pPr>
+            <a:r>
+              <a:rPr sz="1500" b="0" i="0">
+                <a:solidFill>
+                  <a:srgbClr val="9FB6D6"/>
                 </a:solidFill>
                 <a:latin typeface="Calibri"/>
               </a:rPr>
-              <a:t>  ·  Stand V1.2 SP</a:t>
-            </a:r>
-            <a:r>
-              <a:rPr lang="de-DE" sz="1600" b="1" i="0" dirty="0">
-                <a:solidFill>
-                  <a:srgbClr val="B9CDE8"/>
-                </a:solidFill>
-                <a:latin typeface="Calibri"/>
-              </a:rPr>
-              <a:t>2</a:t>
-            </a:r>
-            <a:r>
-              <a:rPr sz="1600" b="1" i="0" dirty="0">
-                <a:solidFill>
-                  <a:srgbClr val="B9CDE8"/>
-                </a:solidFill>
-                <a:latin typeface="Calibri"/>
-              </a:rPr>
-              <a:t>  ·  Juni 2026</a:t>
+              <a:t>Präsentation für die Geschäftsführung</a:t>
             </a:r>
           </a:p>
         </p:txBody>
@@ -3659,7 +3644,7 @@
 </file>
 
 <file path=ppt/slides/slide10.xml><?xml version="1.0" encoding="utf-8"?>
-<p:sld xmlns:a="http://schemas.openxmlformats.org/drawingml/2006/main" xmlns:r="http://schemas.openxmlformats.org/officeDocument/2006/relationships" xmlns:p="http://schemas.openxmlformats.org/presentationml/2006/main">
+<p:sld xmlns:a="http://schemas.openxmlformats.org/drawingml/2006/main" xmlns:p="http://schemas.openxmlformats.org/presentationml/2006/main" xmlns:r="http://schemas.openxmlformats.org/officeDocument/2006/relationships">
   <p:cSld>
     <p:bg>
       <p:bgPr>
@@ -3675,14 +3660,7 @@
         <p:cNvGrpSpPr/>
         <p:nvPr/>
       </p:nvGrpSpPr>
-      <p:grpSpPr>
-        <a:xfrm>
-          <a:off x="0" y="0"/>
-          <a:ext cx="0" cy="0"/>
-          <a:chOff x="0" y="0"/>
-          <a:chExt cx="0" cy="0"/>
-        </a:xfrm>
-      </p:grpSpPr>
+      <p:grpSpPr/>
       <p:sp>
         <p:nvSpPr>
           <p:cNvPr id="2" name="TextBox 1"/>
@@ -3700,7 +3678,7 @@
           <a:noFill/>
         </p:spPr>
         <p:txBody>
-          <a:bodyPr wrap="square" lIns="0" tIns="0" rIns="0" bIns="0" anchor="t">
+          <a:bodyPr wrap="square" anchor="t" lIns="0" rIns="0" tIns="0" bIns="0">
             <a:spAutoFit/>
           </a:bodyPr>
           <a:lstStyle/>
@@ -3745,7 +3723,7 @@
           <a:noFill/>
         </p:spPr>
         <p:txBody>
-          <a:bodyPr wrap="square" lIns="0" tIns="0" rIns="0" bIns="0" anchor="t">
+          <a:bodyPr wrap="square" anchor="t" lIns="0" rIns="0" tIns="0" bIns="0">
             <a:spAutoFit/>
           </a:bodyPr>
           <a:lstStyle/>
@@ -3814,7 +3792,6 @@
           <a:lstStyle/>
           <a:p>
             <a:pPr algn="ctr"/>
-            <a:endParaRPr/>
           </a:p>
         </p:txBody>
       </p:sp>
@@ -3835,7 +3812,7 @@
           <a:noFill/>
         </p:spPr>
         <p:txBody>
-          <a:bodyPr wrap="square" lIns="0" tIns="0" rIns="0" bIns="0" anchor="t">
+          <a:bodyPr wrap="square" anchor="t" lIns="0" rIns="0" tIns="0" bIns="0">
             <a:spAutoFit/>
           </a:bodyPr>
           <a:lstStyle/>
@@ -3904,7 +3881,6 @@
           <a:lstStyle/>
           <a:p>
             <a:pPr algn="ctr"/>
-            <a:endParaRPr/>
           </a:p>
         </p:txBody>
       </p:sp>
@@ -3959,7 +3935,6 @@
           <a:lstStyle/>
           <a:p>
             <a:pPr algn="ctr"/>
-            <a:endParaRPr/>
           </a:p>
         </p:txBody>
       </p:sp>
@@ -4006,7 +3981,6 @@
           <a:lstStyle/>
           <a:p>
             <a:pPr algn="ctr"/>
-            <a:endParaRPr/>
           </a:p>
         </p:txBody>
       </p:sp>
@@ -4018,8 +3992,8 @@
         </p:nvSpPr>
         <p:spPr>
           <a:xfrm>
-            <a:off x="640080" y="3785224"/>
-            <a:ext cx="2240280" cy="238527"/>
+            <a:off x="640080" y="3584448"/>
+            <a:ext cx="2240280" cy="640080"/>
           </a:xfrm>
           <a:prstGeom prst="rect">
             <a:avLst/>
@@ -4027,7 +4001,7 @@
           <a:noFill/>
         </p:spPr>
         <p:txBody>
-          <a:bodyPr wrap="square" lIns="0" tIns="0" rIns="0" bIns="0" anchor="ctr">
+          <a:bodyPr wrap="square" anchor="ctr" lIns="0" rIns="0" tIns="0" bIns="0">
             <a:spAutoFit/>
           </a:bodyPr>
           <a:lstStyle/>
@@ -4044,65 +4018,14 @@
               </a:spcAft>
             </a:pPr>
             <a:r>
-              <a:rPr sz="1550" b="1" i="0" dirty="0">
+              <a:rPr sz="1550" b="1" i="0">
                 <a:solidFill>
                   <a:srgbClr val="1B2633"/>
                 </a:solidFill>
                 <a:latin typeface="Trebuchet MS"/>
               </a:rPr>
-              <a:t>V1.2 SP</a:t>
-            </a:r>
-            <a:r>
-              <a:rPr lang="de-DE" sz="1550" b="1" i="0" dirty="0">
-                <a:solidFill>
-                  <a:srgbClr val="1B2633"/>
-                </a:solidFill>
-                <a:latin typeface="Trebuchet MS"/>
-              </a:rPr>
-              <a:t>2</a:t>
-            </a:r>
-            <a:r>
-              <a:rPr sz="1550" b="1" i="0" dirty="0">
-                <a:solidFill>
-                  <a:srgbClr val="1B2633"/>
-                </a:solidFill>
-                <a:latin typeface="Trebuchet MS"/>
-              </a:rPr>
-              <a:t> </a:t>
-            </a:r>
-            <a:r>
-              <a:rPr sz="1550" b="1" i="0" dirty="0" err="1">
-                <a:solidFill>
-                  <a:srgbClr val="1B2633"/>
-                </a:solidFill>
-                <a:latin typeface="Trebuchet MS"/>
-              </a:rPr>
-              <a:t>im</a:t>
-            </a:r>
-            <a:r>
-              <a:rPr sz="1550" b="1" i="0" dirty="0">
-                <a:solidFill>
-                  <a:srgbClr val="1B2633"/>
-                </a:solidFill>
-                <a:latin typeface="Trebuchet MS"/>
-              </a:rPr>
-              <a:t> </a:t>
-            </a:r>
-            <a:r>
-              <a:rPr lang="de-DE" sz="1550" b="1" dirty="0">
-                <a:solidFill>
-                  <a:srgbClr val="1B2633"/>
-                </a:solidFill>
-                <a:latin typeface="Trebuchet MS"/>
-              </a:rPr>
-              <a:t>Test</a:t>
-            </a:r>
-            <a:endParaRPr sz="1550" b="1" i="0" dirty="0">
-              <a:solidFill>
-                <a:srgbClr val="1B2633"/>
-              </a:solidFill>
-              <a:latin typeface="Trebuchet MS"/>
-            </a:endParaRPr>
+              <a:t>V2.0 im Einsatz</a:t>
+            </a:r>
           </a:p>
         </p:txBody>
       </p:sp>
@@ -4123,7 +4046,7 @@
           <a:noFill/>
         </p:spPr>
         <p:txBody>
-          <a:bodyPr wrap="square" lIns="0" tIns="0" rIns="0" bIns="0" anchor="t">
+          <a:bodyPr wrap="square" anchor="t" lIns="0" rIns="0" tIns="0" bIns="0">
             <a:spAutoFit/>
           </a:bodyPr>
           <a:lstStyle/>
@@ -4146,7 +4069,7 @@
                 </a:solidFill>
                 <a:latin typeface="Calibri"/>
               </a:rPr>
-              <a:t>Kasse, Rabatte und Analyse</a:t>
+              <a:t>Bedarfsanalyse, Mitarbeiter,</a:t>
             </a:r>
           </a:p>
           <a:p>
@@ -4168,7 +4091,7 @@
                 </a:solidFill>
                 <a:latin typeface="Calibri"/>
               </a:rPr>
-              <a:t>produktiv nutzbar</a:t>
+              <a:t>Hilfe &amp; Report neu dabei</a:t>
             </a:r>
           </a:p>
         </p:txBody>
@@ -4190,7 +4113,7 @@
           <a:noFill/>
         </p:spPr>
         <p:txBody>
-          <a:bodyPr wrap="square" lIns="0" tIns="0" rIns="0" bIns="0" anchor="t">
+          <a:bodyPr wrap="square" anchor="t" lIns="0" rIns="0" tIns="0" bIns="0">
             <a:spAutoFit/>
           </a:bodyPr>
           <a:lstStyle/>
@@ -4213,7 +4136,7 @@
                 </a:solidFill>
                 <a:latin typeface="Calibri"/>
               </a:rPr>
-              <a:t>GEPLANT</a:t>
+              <a:t>IN ARBEIT</a:t>
             </a:r>
           </a:p>
         </p:txBody>
@@ -4259,7 +4182,6 @@
           <a:lstStyle/>
           <a:p>
             <a:pPr algn="ctr"/>
-            <a:endParaRPr/>
           </a:p>
         </p:txBody>
       </p:sp>
@@ -4314,7 +4236,6 @@
           <a:lstStyle/>
           <a:p>
             <a:pPr algn="ctr"/>
-            <a:endParaRPr/>
           </a:p>
         </p:txBody>
       </p:sp>
@@ -4361,7 +4282,6 @@
           <a:lstStyle/>
           <a:p>
             <a:pPr algn="ctr"/>
-            <a:endParaRPr/>
           </a:p>
         </p:txBody>
       </p:sp>
@@ -4382,7 +4302,7 @@
           <a:noFill/>
         </p:spPr>
         <p:txBody>
-          <a:bodyPr wrap="square" lIns="0" tIns="0" rIns="0" bIns="0" anchor="ctr">
+          <a:bodyPr wrap="square" anchor="ctr" lIns="0" rIns="0" tIns="0" bIns="0">
             <a:spAutoFit/>
           </a:bodyPr>
           <a:lstStyle/>
@@ -4405,7 +4325,7 @@
                 </a:solidFill>
                 <a:latin typeface="Trebuchet MS"/>
               </a:rPr>
-              <a:t>Mitarbeiter-Programm</a:t>
+              <a:t>Organigramm-Grafik</a:t>
             </a:r>
           </a:p>
         </p:txBody>
@@ -4427,7 +4347,7 @@
           <a:noFill/>
         </p:spPr>
         <p:txBody>
-          <a:bodyPr wrap="square" lIns="0" tIns="0" rIns="0" bIns="0" anchor="t">
+          <a:bodyPr wrap="square" anchor="t" lIns="0" rIns="0" tIns="0" bIns="0">
             <a:spAutoFit/>
           </a:bodyPr>
           <a:lstStyle/>
@@ -4450,7 +4370,7 @@
                 </a:solidFill>
                 <a:latin typeface="Calibri"/>
               </a:rPr>
-              <a:t>Wer macht was, Organigramm</a:t>
+              <a:t>Mitarbeiter-Struktur</a:t>
             </a:r>
           </a:p>
           <a:p>
@@ -4472,7 +4392,7 @@
                 </a:solidFill>
                 <a:latin typeface="Calibri"/>
               </a:rPr>
-              <a:t>&amp; Zuständigkeiten</a:t>
+              <a:t>visuell darstellen</a:t>
             </a:r>
           </a:p>
         </p:txBody>
@@ -4494,7 +4414,7 @@
           <a:noFill/>
         </p:spPr>
         <p:txBody>
-          <a:bodyPr wrap="square" lIns="0" tIns="0" rIns="0" bIns="0" anchor="t">
+          <a:bodyPr wrap="square" anchor="t" lIns="0" rIns="0" tIns="0" bIns="0">
             <a:spAutoFit/>
           </a:bodyPr>
           <a:lstStyle/>
@@ -4563,7 +4483,6 @@
           <a:lstStyle/>
           <a:p>
             <a:pPr algn="ctr"/>
-            <a:endParaRPr/>
           </a:p>
         </p:txBody>
       </p:sp>
@@ -4618,7 +4537,6 @@
           <a:lstStyle/>
           <a:p>
             <a:pPr algn="ctr"/>
-            <a:endParaRPr/>
           </a:p>
         </p:txBody>
       </p:sp>
@@ -4665,7 +4583,6 @@
           <a:lstStyle/>
           <a:p>
             <a:pPr algn="ctr"/>
-            <a:endParaRPr/>
           </a:p>
         </p:txBody>
       </p:sp>
@@ -4686,7 +4603,7 @@
           <a:noFill/>
         </p:spPr>
         <p:txBody>
-          <a:bodyPr wrap="square" lIns="0" tIns="0" rIns="0" bIns="0" anchor="ctr">
+          <a:bodyPr wrap="square" anchor="ctr" lIns="0" rIns="0" tIns="0" bIns="0">
             <a:spAutoFit/>
           </a:bodyPr>
           <a:lstStyle/>
@@ -4709,7 +4626,7 @@
                 </a:solidFill>
                 <a:latin typeface="Trebuchet MS"/>
               </a:rPr>
-              <a:t>Report-Programm</a:t>
+              <a:t>Biosimilar-Wissen</a:t>
             </a:r>
           </a:p>
         </p:txBody>
@@ -4731,7 +4648,7 @@
           <a:noFill/>
         </p:spPr>
         <p:txBody>
-          <a:bodyPr wrap="square" lIns="0" tIns="0" rIns="0" bIns="0" anchor="t">
+          <a:bodyPr wrap="square" anchor="t" lIns="0" rIns="0" tIns="0" bIns="0">
             <a:spAutoFit/>
           </a:bodyPr>
           <a:lstStyle/>
@@ -4754,7 +4671,7 @@
                 </a:solidFill>
                 <a:latin typeface="Calibri"/>
               </a:rPr>
-              <a:t>Modulübergreifende</a:t>
+              <a:t>Wirkstoff-Zuordnung in</a:t>
             </a:r>
           </a:p>
           <a:p>
@@ -4776,7 +4693,7 @@
                 </a:solidFill>
                 <a:latin typeface="Calibri"/>
               </a:rPr>
-              <a:t>Auswertung aller Module</a:t>
+              <a:t>der Bedarfsanalyse</a:t>
             </a:r>
           </a:p>
         </p:txBody>
@@ -4798,7 +4715,7 @@
           <a:noFill/>
         </p:spPr>
         <p:txBody>
-          <a:bodyPr wrap="square" lIns="0" tIns="0" rIns="0" bIns="0" anchor="t">
+          <a:bodyPr wrap="square" anchor="t" lIns="0" rIns="0" tIns="0" bIns="0">
             <a:spAutoFit/>
           </a:bodyPr>
           <a:lstStyle/>
@@ -4867,7 +4784,6 @@
           <a:lstStyle/>
           <a:p>
             <a:pPr algn="ctr"/>
-            <a:endParaRPr/>
           </a:p>
         </p:txBody>
       </p:sp>
@@ -4922,7 +4838,6 @@
           <a:lstStyle/>
           <a:p>
             <a:pPr algn="ctr"/>
-            <a:endParaRPr/>
           </a:p>
         </p:txBody>
       </p:sp>
@@ -4969,7 +4884,6 @@
           <a:lstStyle/>
           <a:p>
             <a:pPr algn="ctr"/>
-            <a:endParaRPr/>
           </a:p>
         </p:txBody>
       </p:sp>
@@ -4990,7 +4904,7 @@
           <a:noFill/>
         </p:spPr>
         <p:txBody>
-          <a:bodyPr wrap="square" lIns="0" tIns="0" rIns="0" bIns="0" anchor="ctr">
+          <a:bodyPr wrap="square" anchor="ctr" lIns="0" rIns="0" tIns="0" bIns="0">
             <a:spAutoFit/>
           </a:bodyPr>
           <a:lstStyle/>
@@ -5035,7 +4949,7 @@
           <a:noFill/>
         </p:spPr>
         <p:txBody>
-          <a:bodyPr wrap="square" lIns="0" tIns="0" rIns="0" bIns="0" anchor="t">
+          <a:bodyPr wrap="square" anchor="t" lIns="0" rIns="0" tIns="0" bIns="0">
             <a:spAutoFit/>
           </a:bodyPr>
           <a:lstStyle/>
@@ -5102,7 +5016,7 @@
           <a:noFill/>
         </p:spPr>
         <p:txBody>
-          <a:bodyPr wrap="square" lIns="0" tIns="0" rIns="0" bIns="0" anchor="t">
+          <a:bodyPr wrap="square" anchor="t" lIns="0" rIns="0" tIns="0" bIns="0">
             <a:spAutoFit/>
           </a:bodyPr>
           <a:lstStyle/>
@@ -5139,7 +5053,7 @@
 </file>
 
 <file path=ppt/slides/slide11.xml><?xml version="1.0" encoding="utf-8"?>
-<p:sld xmlns:a="http://schemas.openxmlformats.org/drawingml/2006/main" xmlns:r="http://schemas.openxmlformats.org/officeDocument/2006/relationships" xmlns:p="http://schemas.openxmlformats.org/presentationml/2006/main">
+<p:sld xmlns:a="http://schemas.openxmlformats.org/drawingml/2006/main" xmlns:p="http://schemas.openxmlformats.org/presentationml/2006/main" xmlns:r="http://schemas.openxmlformats.org/officeDocument/2006/relationships">
   <p:cSld>
     <p:bg>
       <p:bgPr>
@@ -5155,14 +5069,7 @@
         <p:cNvGrpSpPr/>
         <p:nvPr/>
       </p:nvGrpSpPr>
-      <p:grpSpPr>
-        <a:xfrm>
-          <a:off x="0" y="0"/>
-          <a:ext cx="0" cy="0"/>
-          <a:chOff x="0" y="0"/>
-          <a:chExt cx="0" cy="0"/>
-        </a:xfrm>
-      </p:grpSpPr>
+      <p:grpSpPr/>
       <p:sp>
         <p:nvSpPr>
           <p:cNvPr id="2" name="TextBox 1"/>
@@ -5180,7 +5087,7 @@
           <a:noFill/>
         </p:spPr>
         <p:txBody>
-          <a:bodyPr wrap="square" lIns="0" tIns="0" rIns="0" bIns="0" anchor="t">
+          <a:bodyPr wrap="square" anchor="t" lIns="0" rIns="0" tIns="0" bIns="0">
             <a:spAutoFit/>
           </a:bodyPr>
           <a:lstStyle/>
@@ -5225,7 +5132,7 @@
           <a:noFill/>
         </p:spPr>
         <p:txBody>
-          <a:bodyPr wrap="square" lIns="0" tIns="0" rIns="0" bIns="0" anchor="t">
+          <a:bodyPr wrap="square" anchor="t" lIns="0" rIns="0" tIns="0" bIns="0">
             <a:spAutoFit/>
           </a:bodyPr>
           <a:lstStyle/>
@@ -5296,7 +5203,6 @@
           <a:lstStyle/>
           <a:p>
             <a:pPr algn="ctr"/>
-            <a:endParaRPr/>
           </a:p>
         </p:txBody>
       </p:sp>
@@ -5317,7 +5223,7 @@
           <a:noFill/>
         </p:spPr>
         <p:txBody>
-          <a:bodyPr wrap="square" lIns="0" tIns="0" rIns="0" bIns="0" anchor="ctr">
+          <a:bodyPr wrap="square" anchor="ctr" lIns="0" rIns="0" tIns="0" bIns="0">
             <a:spAutoFit/>
           </a:bodyPr>
           <a:lstStyle/>
@@ -5362,7 +5268,7 @@
           <a:noFill/>
         </p:spPr>
         <p:txBody>
-          <a:bodyPr wrap="square" lIns="0" tIns="0" rIns="0" bIns="0" anchor="t">
+          <a:bodyPr wrap="square" anchor="t" lIns="0" rIns="0" tIns="0" bIns="0">
             <a:spAutoFit/>
           </a:bodyPr>
           <a:lstStyle/>
@@ -5455,7 +5361,6 @@
           <a:lstStyle/>
           <a:p>
             <a:pPr algn="ctr"/>
-            <a:endParaRPr/>
           </a:p>
         </p:txBody>
       </p:sp>
@@ -5476,7 +5381,7 @@
           <a:noFill/>
         </p:spPr>
         <p:txBody>
-          <a:bodyPr wrap="square" lIns="0" tIns="0" rIns="0" bIns="0" anchor="ctr">
+          <a:bodyPr wrap="square" anchor="ctr" lIns="0" rIns="0" tIns="0" bIns="0">
             <a:spAutoFit/>
           </a:bodyPr>
           <a:lstStyle/>
@@ -5521,7 +5426,7 @@
           <a:noFill/>
         </p:spPr>
         <p:txBody>
-          <a:bodyPr wrap="square" lIns="0" tIns="0" rIns="0" bIns="0" anchor="t">
+          <a:bodyPr wrap="square" anchor="t" lIns="0" rIns="0" tIns="0" bIns="0">
             <a:spAutoFit/>
           </a:bodyPr>
           <a:lstStyle/>
@@ -5614,7 +5519,6 @@
           <a:lstStyle/>
           <a:p>
             <a:pPr algn="ctr"/>
-            <a:endParaRPr/>
           </a:p>
         </p:txBody>
       </p:sp>
@@ -5635,7 +5539,7 @@
           <a:noFill/>
         </p:spPr>
         <p:txBody>
-          <a:bodyPr wrap="square" lIns="0" tIns="0" rIns="0" bIns="0" anchor="ctr">
+          <a:bodyPr wrap="square" anchor="ctr" lIns="0" rIns="0" tIns="0" bIns="0">
             <a:spAutoFit/>
           </a:bodyPr>
           <a:lstStyle/>
@@ -5680,7 +5584,7 @@
           <a:noFill/>
         </p:spPr>
         <p:txBody>
-          <a:bodyPr wrap="square" lIns="0" tIns="0" rIns="0" bIns="0" anchor="t">
+          <a:bodyPr wrap="square" anchor="t" lIns="0" rIns="0" tIns="0" bIns="0">
             <a:spAutoFit/>
           </a:bodyPr>
           <a:lstStyle/>
@@ -5773,7 +5677,6 @@
           <a:lstStyle/>
           <a:p>
             <a:pPr algn="ctr"/>
-            <a:endParaRPr/>
           </a:p>
         </p:txBody>
       </p:sp>
@@ -5794,7 +5697,7 @@
           <a:noFill/>
         </p:spPr>
         <p:txBody>
-          <a:bodyPr wrap="square" lIns="0" tIns="0" rIns="0" bIns="0" anchor="ctr">
+          <a:bodyPr wrap="square" anchor="ctr" lIns="0" rIns="0" tIns="0" bIns="0">
             <a:spAutoFit/>
           </a:bodyPr>
           <a:lstStyle/>
@@ -5839,7 +5742,7 @@
           <a:noFill/>
         </p:spPr>
         <p:txBody>
-          <a:bodyPr wrap="square" lIns="0" tIns="0" rIns="0" bIns="0" anchor="t">
+          <a:bodyPr wrap="square" anchor="t" lIns="0" rIns="0" tIns="0" bIns="0">
             <a:spAutoFit/>
           </a:bodyPr>
           <a:lstStyle/>
@@ -5940,7 +5843,6 @@
           <a:lstStyle/>
           <a:p>
             <a:pPr algn="ctr"/>
-            <a:endParaRPr/>
           </a:p>
         </p:txBody>
       </p:sp>
@@ -5985,7 +5887,6 @@
           <a:lstStyle/>
           <a:p>
             <a:pPr algn="ctr"/>
-            <a:endParaRPr/>
           </a:p>
         </p:txBody>
       </p:sp>
@@ -6006,7 +5907,7 @@
           <a:noFill/>
         </p:spPr>
         <p:txBody>
-          <a:bodyPr wrap="square" lIns="0" tIns="0" rIns="0" bIns="0" anchor="ctr">
+          <a:bodyPr wrap="square" anchor="ctr" lIns="0" rIns="0" tIns="0" bIns="0">
             <a:spAutoFit/>
           </a:bodyPr>
           <a:lstStyle/>
@@ -6107,7 +6008,6 @@
           <a:lstStyle/>
           <a:p>
             <a:pPr algn="ctr"/>
-            <a:endParaRPr/>
           </a:p>
         </p:txBody>
       </p:sp>
@@ -6152,7 +6052,6 @@
           <a:lstStyle/>
           <a:p>
             <a:pPr algn="ctr"/>
-            <a:endParaRPr/>
           </a:p>
         </p:txBody>
       </p:sp>
@@ -6173,7 +6072,7 @@
           <a:noFill/>
         </p:spPr>
         <p:txBody>
-          <a:bodyPr wrap="square" lIns="0" tIns="0" rIns="0" bIns="0" anchor="ctr">
+          <a:bodyPr wrap="square" anchor="ctr" lIns="0" rIns="0" tIns="0" bIns="0">
             <a:spAutoFit/>
           </a:bodyPr>
           <a:lstStyle/>
@@ -6264,7 +6163,6 @@
           <a:lstStyle/>
           <a:p>
             <a:pPr algn="ctr"/>
-            <a:endParaRPr/>
           </a:p>
         </p:txBody>
       </p:sp>
@@ -6309,7 +6207,6 @@
           <a:lstStyle/>
           <a:p>
             <a:pPr algn="ctr"/>
-            <a:endParaRPr/>
           </a:p>
         </p:txBody>
       </p:sp>
@@ -6362,7 +6259,6 @@
           <a:lstStyle/>
           <a:p>
             <a:pPr algn="ctr"/>
-            <a:endParaRPr/>
           </a:p>
         </p:txBody>
       </p:sp>
@@ -6383,7 +6279,7 @@
           <a:noFill/>
         </p:spPr>
         <p:txBody>
-          <a:bodyPr wrap="square" lIns="0" tIns="0" rIns="0" bIns="0" anchor="ctr">
+          <a:bodyPr wrap="square" anchor="ctr" lIns="0" rIns="0" tIns="0" bIns="0">
             <a:spAutoFit/>
           </a:bodyPr>
           <a:lstStyle/>
@@ -6474,7 +6370,6 @@
           <a:lstStyle/>
           <a:p>
             <a:pPr algn="ctr"/>
-            <a:endParaRPr/>
           </a:p>
         </p:txBody>
       </p:sp>
@@ -6527,7 +6422,6 @@
           <a:lstStyle/>
           <a:p>
             <a:pPr algn="ctr"/>
-            <a:endParaRPr/>
           </a:p>
         </p:txBody>
       </p:sp>
@@ -6548,7 +6442,7 @@
           <a:noFill/>
         </p:spPr>
         <p:txBody>
-          <a:bodyPr wrap="square" lIns="0" tIns="0" rIns="0" bIns="0" anchor="ctr">
+          <a:bodyPr wrap="square" anchor="ctr" lIns="0" rIns="0" tIns="0" bIns="0">
             <a:spAutoFit/>
           </a:bodyPr>
           <a:lstStyle/>
@@ -6615,7 +6509,7 @@
           <a:noFill/>
         </p:spPr>
         <p:txBody>
-          <a:bodyPr wrap="square" lIns="0" tIns="0" rIns="0" bIns="0" anchor="t">
+          <a:bodyPr wrap="square" anchor="t" lIns="0" rIns="0" tIns="0" bIns="0">
             <a:spAutoFit/>
           </a:bodyPr>
           <a:lstStyle/>
@@ -6700,7 +6594,7 @@
           <a:noFill/>
         </p:spPr>
         <p:txBody>
-          <a:bodyPr wrap="square" lIns="0" tIns="0" rIns="0" bIns="0" anchor="t">
+          <a:bodyPr wrap="square" anchor="t" lIns="0" rIns="0" tIns="0" bIns="0">
             <a:spAutoFit/>
           </a:bodyPr>
           <a:lstStyle/>
@@ -6737,7 +6631,7 @@
 </file>
 
 <file path=ppt/slides/slide12.xml><?xml version="1.0" encoding="utf-8"?>
-<p:sld xmlns:a="http://schemas.openxmlformats.org/drawingml/2006/main" xmlns:r="http://schemas.openxmlformats.org/officeDocument/2006/relationships" xmlns:p="http://schemas.openxmlformats.org/presentationml/2006/main">
+<p:sld xmlns:a="http://schemas.openxmlformats.org/drawingml/2006/main" xmlns:p="http://schemas.openxmlformats.org/presentationml/2006/main" xmlns:r="http://schemas.openxmlformats.org/officeDocument/2006/relationships">
   <p:cSld>
     <p:bg>
       <p:bgPr>
@@ -6753,14 +6647,7 @@
         <p:cNvGrpSpPr/>
         <p:nvPr/>
       </p:nvGrpSpPr>
-      <p:grpSpPr>
-        <a:xfrm>
-          <a:off x="0" y="0"/>
-          <a:ext cx="0" cy="0"/>
-          <a:chOff x="0" y="0"/>
-          <a:chExt cx="0" cy="0"/>
-        </a:xfrm>
-      </p:grpSpPr>
+      <p:grpSpPr/>
       <p:sp>
         <p:nvSpPr>
           <p:cNvPr id="2" name="Rectangle 1"/>
@@ -6802,7 +6689,6 @@
           <a:lstStyle/>
           <a:p>
             <a:pPr algn="ctr"/>
-            <a:endParaRPr/>
           </a:p>
         </p:txBody>
       </p:sp>
@@ -6849,7 +6735,6 @@
           <a:lstStyle/>
           <a:p>
             <a:pPr algn="ctr"/>
-            <a:endParaRPr/>
           </a:p>
         </p:txBody>
       </p:sp>
@@ -6896,7 +6781,6 @@
           <a:lstStyle/>
           <a:p>
             <a:pPr algn="ctr"/>
-            <a:endParaRPr/>
           </a:p>
         </p:txBody>
       </p:sp>
@@ -6943,7 +6827,6 @@
           <a:lstStyle/>
           <a:p>
             <a:pPr algn="ctr"/>
-            <a:endParaRPr/>
           </a:p>
         </p:txBody>
       </p:sp>
@@ -6990,7 +6873,6 @@
           <a:lstStyle/>
           <a:p>
             <a:pPr algn="ctr"/>
-            <a:endParaRPr/>
           </a:p>
         </p:txBody>
       </p:sp>
@@ -7037,7 +6919,6 @@
           <a:lstStyle/>
           <a:p>
             <a:pPr algn="ctr"/>
-            <a:endParaRPr/>
           </a:p>
         </p:txBody>
       </p:sp>
@@ -7084,7 +6965,6 @@
           <a:lstStyle/>
           <a:p>
             <a:pPr algn="ctr"/>
-            <a:endParaRPr/>
           </a:p>
         </p:txBody>
       </p:sp>
@@ -7097,7 +6977,7 @@
         <p:spPr>
           <a:xfrm>
             <a:off x="914400" y="2286000"/>
-            <a:ext cx="10332720" cy="1256754"/>
+            <a:ext cx="10332720" cy="1463040"/>
           </a:xfrm>
           <a:prstGeom prst="rect">
             <a:avLst/>
@@ -7105,7 +6985,7 @@
           <a:noFill/>
         </p:spPr>
         <p:txBody>
-          <a:bodyPr wrap="square" lIns="0" tIns="0" rIns="0" bIns="0" anchor="t">
+          <a:bodyPr wrap="square" anchor="t" lIns="0" rIns="0" tIns="0" bIns="0">
             <a:spAutoFit/>
           </a:bodyPr>
           <a:lstStyle/>
@@ -7122,107 +7002,35 @@
               </a:spcAft>
             </a:pPr>
             <a:r>
-              <a:rPr sz="4000" b="1" i="0" dirty="0">
+              <a:rPr sz="4000" b="1" i="0">
                 <a:solidFill>
                   <a:srgbClr val="FFFFFF"/>
                 </a:solidFill>
                 <a:latin typeface="Trebuchet MS"/>
               </a:rPr>
-              <a:t>Eine </a:t>
-            </a:r>
-            <a:r>
-              <a:rPr sz="4000" b="1" i="0" dirty="0" err="1">
-                <a:solidFill>
-                  <a:srgbClr val="FFFFFF"/>
+              <a:t>Eine Plattform. Alle Prozesse.</a:t>
+            </a:r>
+          </a:p>
+          <a:p>
+            <a:pPr algn="l">
+              <a:lnSpc>
+                <a:spcPct val="100000"/>
+              </a:lnSpc>
+              <a:spcBef>
+                <a:spcPts val="0"/>
+              </a:spcBef>
+              <a:spcAft>
+                <a:spcPts val="200"/>
+              </a:spcAft>
+            </a:pPr>
+            <a:r>
+              <a:rPr sz="4000" b="1" i="0">
+                <a:solidFill>
+                  <a:srgbClr val="3867B7"/>
                 </a:solidFill>
                 <a:latin typeface="Trebuchet MS"/>
               </a:rPr>
-              <a:t>Plattform</a:t>
-            </a:r>
-            <a:r>
-              <a:rPr sz="4000" b="1" i="0" dirty="0">
-                <a:solidFill>
-                  <a:srgbClr val="FFFFFF"/>
-                </a:solidFill>
-                <a:latin typeface="Trebuchet MS"/>
-              </a:rPr>
-              <a:t>. Alle </a:t>
-            </a:r>
-            <a:r>
-              <a:rPr sz="4000" b="1" i="0" dirty="0" err="1">
-                <a:solidFill>
-                  <a:srgbClr val="FFFFFF"/>
-                </a:solidFill>
-                <a:latin typeface="Trebuchet MS"/>
-              </a:rPr>
-              <a:t>Prozesse</a:t>
-            </a:r>
-            <a:r>
-              <a:rPr sz="4000" b="1" i="0" dirty="0">
-                <a:solidFill>
-                  <a:srgbClr val="FFFFFF"/>
-                </a:solidFill>
-                <a:latin typeface="Trebuchet MS"/>
-              </a:rPr>
-              <a:t>.</a:t>
-            </a:r>
-          </a:p>
-          <a:p>
-            <a:pPr algn="l">
-              <a:lnSpc>
-                <a:spcPct val="100000"/>
-              </a:lnSpc>
-              <a:spcBef>
-                <a:spcPts val="0"/>
-              </a:spcBef>
-              <a:spcAft>
-                <a:spcPts val="200"/>
-              </a:spcAft>
-            </a:pPr>
-            <a:r>
-              <a:rPr lang="de-DE" sz="4000" b="1" dirty="0">
-                <a:solidFill>
-                  <a:srgbClr val="3867B7"/>
-                </a:solidFill>
-                <a:latin typeface="Trebuchet MS"/>
-              </a:rPr>
-              <a:t>Für NMG-</a:t>
-            </a:r>
-            <a:r>
-              <a:rPr lang="de-DE" sz="4000" b="1" dirty="0" err="1">
-                <a:solidFill>
-                  <a:srgbClr val="3867B7"/>
-                </a:solidFill>
-                <a:latin typeface="Trebuchet MS"/>
-              </a:rPr>
-              <a:t>Pharma</a:t>
-            </a:r>
-            <a:r>
-              <a:rPr sz="4000" b="1" i="0" dirty="0">
-                <a:solidFill>
-                  <a:srgbClr val="3867B7"/>
-                </a:solidFill>
-                <a:latin typeface="Trebuchet MS"/>
-              </a:rPr>
-              <a:t> </a:t>
-            </a:r>
-            <a:r>
-              <a:rPr sz="4000" b="1" i="0" dirty="0" err="1">
-                <a:solidFill>
-                  <a:srgbClr val="3867B7"/>
-                </a:solidFill>
-                <a:latin typeface="Trebuchet MS"/>
-              </a:rPr>
-              <a:t>gebaut</a:t>
-            </a:r>
-            <a:r>
-              <a:rPr sz="4000" b="1" i="0" dirty="0">
-                <a:solidFill>
-                  <a:srgbClr val="3867B7"/>
-                </a:solidFill>
-                <a:latin typeface="Trebuchet MS"/>
-              </a:rPr>
-              <a:t>.</a:t>
+              <a:t>Im Haus gebaut.</a:t>
             </a:r>
           </a:p>
         </p:txBody>
@@ -7244,7 +7052,7 @@
           <a:noFill/>
         </p:spPr>
         <p:txBody>
-          <a:bodyPr wrap="square" lIns="0" tIns="0" rIns="0" bIns="0" anchor="t">
+          <a:bodyPr wrap="square" anchor="t" lIns="0" rIns="0" tIns="0" bIns="0">
             <a:spAutoFit/>
           </a:bodyPr>
           <a:lstStyle/>
@@ -7313,7 +7121,6 @@
           <a:lstStyle/>
           <a:p>
             <a:pPr algn="ctr"/>
-            <a:endParaRPr/>
           </a:p>
         </p:txBody>
       </p:sp>
@@ -7334,7 +7141,7 @@
           <a:noFill/>
         </p:spPr>
         <p:txBody>
-          <a:bodyPr wrap="square" lIns="0" tIns="0" rIns="0" bIns="0" anchor="t">
+          <a:bodyPr wrap="square" anchor="t" lIns="0" rIns="0" tIns="0" bIns="0">
             <a:spAutoFit/>
           </a:bodyPr>
           <a:lstStyle/>
@@ -7411,7 +7218,6 @@
           <a:lstStyle/>
           <a:p>
             <a:pPr algn="ctr"/>
-            <a:endParaRPr/>
           </a:p>
         </p:txBody>
       </p:sp>
@@ -7448,7 +7254,7 @@
 </file>
 
 <file path=ppt/slides/slide2.xml><?xml version="1.0" encoding="utf-8"?>
-<p:sld xmlns:a="http://schemas.openxmlformats.org/drawingml/2006/main" xmlns:r="http://schemas.openxmlformats.org/officeDocument/2006/relationships" xmlns:p="http://schemas.openxmlformats.org/presentationml/2006/main">
+<p:sld xmlns:a="http://schemas.openxmlformats.org/drawingml/2006/main" xmlns:p="http://schemas.openxmlformats.org/presentationml/2006/main" xmlns:r="http://schemas.openxmlformats.org/officeDocument/2006/relationships">
   <p:cSld>
     <p:bg>
       <p:bgPr>
@@ -7464,14 +7270,7 @@
         <p:cNvGrpSpPr/>
         <p:nvPr/>
       </p:nvGrpSpPr>
-      <p:grpSpPr>
-        <a:xfrm>
-          <a:off x="0" y="0"/>
-          <a:ext cx="0" cy="0"/>
-          <a:chOff x="0" y="0"/>
-          <a:chExt cx="0" cy="0"/>
-        </a:xfrm>
-      </p:grpSpPr>
+      <p:grpSpPr/>
       <p:sp>
         <p:nvSpPr>
           <p:cNvPr id="2" name="TextBox 1"/>
@@ -7489,7 +7288,7 @@
           <a:noFill/>
         </p:spPr>
         <p:txBody>
-          <a:bodyPr wrap="square" lIns="0" tIns="0" rIns="0" bIns="0" anchor="t">
+          <a:bodyPr wrap="square" anchor="t" lIns="0" rIns="0" tIns="0" bIns="0">
             <a:spAutoFit/>
           </a:bodyPr>
           <a:lstStyle/>
@@ -7534,7 +7333,7 @@
           <a:noFill/>
         </p:spPr>
         <p:txBody>
-          <a:bodyPr wrap="square" lIns="0" tIns="0" rIns="0" bIns="0" anchor="t">
+          <a:bodyPr wrap="square" anchor="t" lIns="0" rIns="0" tIns="0" bIns="0">
             <a:spAutoFit/>
           </a:bodyPr>
           <a:lstStyle/>
@@ -7631,7 +7430,6 @@
           <a:lstStyle/>
           <a:p>
             <a:pPr algn="ctr"/>
-            <a:endParaRPr/>
           </a:p>
         </p:txBody>
       </p:sp>
@@ -7678,7 +7476,6 @@
           <a:lstStyle/>
           <a:p>
             <a:pPr algn="ctr"/>
-            <a:endParaRPr/>
           </a:p>
         </p:txBody>
       </p:sp>
@@ -7699,7 +7496,7 @@
           <a:noFill/>
         </p:spPr>
         <p:txBody>
-          <a:bodyPr wrap="square" lIns="0" tIns="0" rIns="0" bIns="0" anchor="ctr">
+          <a:bodyPr wrap="square" anchor="ctr" lIns="0" rIns="0" tIns="0" bIns="0">
             <a:spAutoFit/>
           </a:bodyPr>
           <a:lstStyle/>
@@ -7744,7 +7541,7 @@
           <a:noFill/>
         </p:spPr>
         <p:txBody>
-          <a:bodyPr wrap="square" lIns="0" tIns="0" rIns="0" bIns="0" anchor="t">
+          <a:bodyPr wrap="square" anchor="t" lIns="0" rIns="0" tIns="0" bIns="0">
             <a:spAutoFit/>
           </a:bodyPr>
           <a:lstStyle/>
@@ -7845,7 +7642,6 @@
           <a:lstStyle/>
           <a:p>
             <a:pPr algn="ctr"/>
-            <a:endParaRPr/>
           </a:p>
         </p:txBody>
       </p:sp>
@@ -7892,7 +7688,6 @@
           <a:lstStyle/>
           <a:p>
             <a:pPr algn="ctr"/>
-            <a:endParaRPr/>
           </a:p>
         </p:txBody>
       </p:sp>
@@ -7913,7 +7708,7 @@
           <a:noFill/>
         </p:spPr>
         <p:txBody>
-          <a:bodyPr wrap="square" lIns="0" tIns="0" rIns="0" bIns="0" anchor="ctr">
+          <a:bodyPr wrap="square" anchor="ctr" lIns="0" rIns="0" tIns="0" bIns="0">
             <a:spAutoFit/>
           </a:bodyPr>
           <a:lstStyle/>
@@ -7958,7 +7753,7 @@
           <a:noFill/>
         </p:spPr>
         <p:txBody>
-          <a:bodyPr wrap="square" lIns="0" tIns="0" rIns="0" bIns="0" anchor="t">
+          <a:bodyPr wrap="square" anchor="t" lIns="0" rIns="0" tIns="0" bIns="0">
             <a:spAutoFit/>
           </a:bodyPr>
           <a:lstStyle/>
@@ -8059,7 +7854,6 @@
           <a:lstStyle/>
           <a:p>
             <a:pPr algn="ctr"/>
-            <a:endParaRPr/>
           </a:p>
         </p:txBody>
       </p:sp>
@@ -8106,7 +7900,6 @@
           <a:lstStyle/>
           <a:p>
             <a:pPr algn="ctr"/>
-            <a:endParaRPr/>
           </a:p>
         </p:txBody>
       </p:sp>
@@ -8118,8 +7911,8 @@
         </p:nvSpPr>
         <p:spPr>
           <a:xfrm>
-            <a:off x="6373368" y="3320385"/>
-            <a:ext cx="2148840" cy="400110"/>
+            <a:off x="6373368" y="3063240"/>
+            <a:ext cx="2148840" cy="914400"/>
           </a:xfrm>
           <a:prstGeom prst="rect">
             <a:avLst/>
@@ -8127,7 +7920,7 @@
           <a:noFill/>
         </p:spPr>
         <p:txBody>
-          <a:bodyPr wrap="square" lIns="0" tIns="0" rIns="0" bIns="0" anchor="ctr">
+          <a:bodyPr wrap="square" anchor="ctr" lIns="0" rIns="0" tIns="0" bIns="0">
             <a:spAutoFit/>
           </a:bodyPr>
           <a:lstStyle/>
@@ -8144,29 +7937,14 @@
               </a:spcAft>
             </a:pPr>
             <a:r>
-              <a:rPr sz="2600" b="1" i="0" dirty="0">
+              <a:rPr sz="3200" b="1" i="0">
                 <a:solidFill>
                   <a:srgbClr val="8B5A00"/>
                 </a:solidFill>
                 <a:latin typeface="Trebuchet MS"/>
               </a:rPr>
-              <a:t>V1.2 SP</a:t>
-            </a:r>
-            <a:r>
-              <a:rPr lang="de-DE" sz="2600" b="1" i="0" dirty="0">
-                <a:solidFill>
-                  <a:srgbClr val="8B5A00"/>
-                </a:solidFill>
-                <a:latin typeface="Trebuchet MS"/>
-              </a:rPr>
-              <a:t>2</a:t>
-            </a:r>
-            <a:endParaRPr sz="2600" b="1" i="0" dirty="0">
-              <a:solidFill>
-                <a:srgbClr val="8B5A00"/>
-              </a:solidFill>
-              <a:latin typeface="Trebuchet MS"/>
-            </a:endParaRPr>
+              <a:t>V2.0</a:t>
+            </a:r>
           </a:p>
         </p:txBody>
       </p:sp>
@@ -8187,7 +7965,7 @@
           <a:noFill/>
         </p:spPr>
         <p:txBody>
-          <a:bodyPr wrap="square" lIns="0" tIns="0" rIns="0" bIns="0" anchor="t">
+          <a:bodyPr wrap="square" anchor="t" lIns="0" rIns="0" tIns="0" bIns="0">
             <a:spAutoFit/>
           </a:bodyPr>
           <a:lstStyle/>
@@ -8288,7 +8066,6 @@
           <a:lstStyle/>
           <a:p>
             <a:pPr algn="ctr"/>
-            <a:endParaRPr/>
           </a:p>
         </p:txBody>
       </p:sp>
@@ -8335,7 +8112,6 @@
           <a:lstStyle/>
           <a:p>
             <a:pPr algn="ctr"/>
-            <a:endParaRPr/>
           </a:p>
         </p:txBody>
       </p:sp>
@@ -8356,7 +8132,7 @@
           <a:noFill/>
         </p:spPr>
         <p:txBody>
-          <a:bodyPr wrap="square" lIns="0" tIns="0" rIns="0" bIns="0" anchor="ctr">
+          <a:bodyPr wrap="square" anchor="ctr" lIns="0" rIns="0" tIns="0" bIns="0">
             <a:spAutoFit/>
           </a:bodyPr>
           <a:lstStyle/>
@@ -8401,7 +8177,7 @@
           <a:noFill/>
         </p:spPr>
         <p:txBody>
-          <a:bodyPr wrap="square" lIns="0" tIns="0" rIns="0" bIns="0" anchor="t">
+          <a:bodyPr wrap="square" anchor="t" lIns="0" rIns="0" tIns="0" bIns="0">
             <a:spAutoFit/>
           </a:bodyPr>
           <a:lstStyle/>
@@ -8468,7 +8244,7 @@
           <a:noFill/>
         </p:spPr>
         <p:txBody>
-          <a:bodyPr wrap="square" lIns="0" tIns="0" rIns="0" bIns="0" anchor="t">
+          <a:bodyPr wrap="square" anchor="t" lIns="0" rIns="0" tIns="0" bIns="0">
             <a:spAutoFit/>
           </a:bodyPr>
           <a:lstStyle/>
@@ -8522,7 +8298,7 @@
           <a:noFill/>
         </p:spPr>
         <p:txBody>
-          <a:bodyPr wrap="square" lIns="0" tIns="0" rIns="0" bIns="0" anchor="t">
+          <a:bodyPr wrap="square" anchor="t" lIns="0" rIns="0" tIns="0" bIns="0">
             <a:spAutoFit/>
           </a:bodyPr>
           <a:lstStyle/>
@@ -8559,7 +8335,7 @@
 </file>
 
 <file path=ppt/slides/slide3.xml><?xml version="1.0" encoding="utf-8"?>
-<p:sld xmlns:a="http://schemas.openxmlformats.org/drawingml/2006/main" xmlns:r="http://schemas.openxmlformats.org/officeDocument/2006/relationships" xmlns:p="http://schemas.openxmlformats.org/presentationml/2006/main">
+<p:sld xmlns:a="http://schemas.openxmlformats.org/drawingml/2006/main" xmlns:p="http://schemas.openxmlformats.org/presentationml/2006/main" xmlns:r="http://schemas.openxmlformats.org/officeDocument/2006/relationships">
   <p:cSld>
     <p:bg>
       <p:bgPr>
@@ -8575,14 +8351,7 @@
         <p:cNvGrpSpPr/>
         <p:nvPr/>
       </p:nvGrpSpPr>
-      <p:grpSpPr>
-        <a:xfrm>
-          <a:off x="0" y="0"/>
-          <a:ext cx="0" cy="0"/>
-          <a:chOff x="0" y="0"/>
-          <a:chExt cx="0" cy="0"/>
-        </a:xfrm>
-      </p:grpSpPr>
+      <p:grpSpPr/>
       <p:sp>
         <p:nvSpPr>
           <p:cNvPr id="2" name="TextBox 1"/>
@@ -8600,7 +8369,7 @@
           <a:noFill/>
         </p:spPr>
         <p:txBody>
-          <a:bodyPr wrap="square" lIns="0" tIns="0" rIns="0" bIns="0" anchor="t">
+          <a:bodyPr wrap="square" anchor="t" lIns="0" rIns="0" tIns="0" bIns="0">
             <a:spAutoFit/>
           </a:bodyPr>
           <a:lstStyle/>
@@ -8645,7 +8414,7 @@
           <a:noFill/>
         </p:spPr>
         <p:txBody>
-          <a:bodyPr wrap="square" lIns="0" tIns="0" rIns="0" bIns="0" anchor="t">
+          <a:bodyPr wrap="square" anchor="t" lIns="0" rIns="0" tIns="0" bIns="0">
             <a:spAutoFit/>
           </a:bodyPr>
           <a:lstStyle/>
@@ -8716,7 +8485,6 @@
           <a:lstStyle/>
           <a:p>
             <a:pPr algn="ctr"/>
-            <a:endParaRPr/>
           </a:p>
         </p:txBody>
       </p:sp>
@@ -8737,7 +8505,7 @@
           <a:noFill/>
         </p:spPr>
         <p:txBody>
-          <a:bodyPr wrap="square" lIns="0" tIns="0" rIns="0" bIns="0" anchor="ctr">
+          <a:bodyPr wrap="square" anchor="ctr" lIns="0" rIns="0" tIns="0" bIns="0">
             <a:spAutoFit/>
           </a:bodyPr>
           <a:lstStyle/>
@@ -8782,7 +8550,7 @@
           <a:noFill/>
         </p:spPr>
         <p:txBody>
-          <a:bodyPr wrap="square" lIns="0" tIns="0" rIns="0" bIns="0" anchor="t">
+          <a:bodyPr wrap="square" anchor="t" lIns="0" rIns="0" tIns="0" bIns="0">
             <a:spAutoFit/>
           </a:bodyPr>
           <a:lstStyle/>
@@ -8875,7 +8643,6 @@
           <a:lstStyle/>
           <a:p>
             <a:pPr algn="ctr"/>
-            <a:endParaRPr/>
           </a:p>
         </p:txBody>
       </p:sp>
@@ -8896,7 +8663,7 @@
           <a:noFill/>
         </p:spPr>
         <p:txBody>
-          <a:bodyPr wrap="square" lIns="0" tIns="0" rIns="0" bIns="0" anchor="ctr">
+          <a:bodyPr wrap="square" anchor="ctr" lIns="0" rIns="0" tIns="0" bIns="0">
             <a:spAutoFit/>
           </a:bodyPr>
           <a:lstStyle/>
@@ -8941,7 +8708,7 @@
           <a:noFill/>
         </p:spPr>
         <p:txBody>
-          <a:bodyPr wrap="square" lIns="0" tIns="0" rIns="0" bIns="0" anchor="t">
+          <a:bodyPr wrap="square" anchor="t" lIns="0" rIns="0" tIns="0" bIns="0">
             <a:spAutoFit/>
           </a:bodyPr>
           <a:lstStyle/>
@@ -9034,7 +8801,6 @@
           <a:lstStyle/>
           <a:p>
             <a:pPr algn="ctr"/>
-            <a:endParaRPr/>
           </a:p>
         </p:txBody>
       </p:sp>
@@ -9055,7 +8821,7 @@
           <a:noFill/>
         </p:spPr>
         <p:txBody>
-          <a:bodyPr wrap="square" lIns="0" tIns="0" rIns="0" bIns="0" anchor="ctr">
+          <a:bodyPr wrap="square" anchor="ctr" lIns="0" rIns="0" tIns="0" bIns="0">
             <a:spAutoFit/>
           </a:bodyPr>
           <a:lstStyle/>
@@ -9100,7 +8866,7 @@
           <a:noFill/>
         </p:spPr>
         <p:txBody>
-          <a:bodyPr wrap="square" lIns="0" tIns="0" rIns="0" bIns="0" anchor="t">
+          <a:bodyPr wrap="square" anchor="t" lIns="0" rIns="0" tIns="0" bIns="0">
             <a:spAutoFit/>
           </a:bodyPr>
           <a:lstStyle/>
@@ -9193,7 +8959,6 @@
           <a:lstStyle/>
           <a:p>
             <a:pPr algn="ctr"/>
-            <a:endParaRPr/>
           </a:p>
         </p:txBody>
       </p:sp>
@@ -9214,7 +8979,7 @@
           <a:noFill/>
         </p:spPr>
         <p:txBody>
-          <a:bodyPr wrap="square" lIns="0" tIns="0" rIns="0" bIns="0" anchor="ctr">
+          <a:bodyPr wrap="square" anchor="ctr" lIns="0" rIns="0" tIns="0" bIns="0">
             <a:spAutoFit/>
           </a:bodyPr>
           <a:lstStyle/>
@@ -9259,7 +9024,7 @@
           <a:noFill/>
         </p:spPr>
         <p:txBody>
-          <a:bodyPr wrap="square" lIns="0" tIns="0" rIns="0" bIns="0" anchor="t">
+          <a:bodyPr wrap="square" anchor="t" lIns="0" rIns="0" tIns="0" bIns="0">
             <a:spAutoFit/>
           </a:bodyPr>
           <a:lstStyle/>
@@ -9358,7 +9123,6 @@
           <a:lstStyle/>
           <a:p>
             <a:pPr algn="ctr"/>
-            <a:endParaRPr/>
           </a:p>
         </p:txBody>
       </p:sp>
@@ -9379,7 +9143,7 @@
           <a:noFill/>
         </p:spPr>
         <p:txBody>
-          <a:bodyPr wrap="square" lIns="0" tIns="0" rIns="0" bIns="0" anchor="t">
+          <a:bodyPr wrap="square" anchor="t" lIns="0" rIns="0" tIns="0" bIns="0">
             <a:spAutoFit/>
           </a:bodyPr>
           <a:lstStyle/>
@@ -9424,7 +9188,7 @@
           <a:noFill/>
         </p:spPr>
         <p:txBody>
-          <a:bodyPr wrap="square" lIns="0" tIns="0" rIns="0" bIns="0" anchor="t">
+          <a:bodyPr wrap="square" anchor="t" lIns="0" rIns="0" tIns="0" bIns="0">
             <a:spAutoFit/>
           </a:bodyPr>
           <a:lstStyle/>
@@ -9462,12 +9226,15 @@
                 <a:spcPts val="300"/>
               </a:spcAft>
             </a:pPr>
-            <a:endParaRPr sz="1500" b="1" i="0">
-              <a:solidFill>
-                <a:srgbClr val="E8F1FB"/>
-              </a:solidFill>
-              <a:latin typeface="Calibri"/>
-            </a:endParaRPr>
+            <a:r>
+              <a:rPr sz="600" b="0" i="0">
+                <a:solidFill>
+                  <a:srgbClr val="E8F1FB"/>
+                </a:solidFill>
+                <a:latin typeface="Calibri"/>
+              </a:rPr>
+              <a:t/>
+            </a:r>
           </a:p>
           <a:p>
             <a:pPr algn="l">
@@ -9503,12 +9270,15 @@
                 <a:spcPts val="300"/>
               </a:spcAft>
             </a:pPr>
-            <a:endParaRPr sz="1450" b="0" i="0">
-              <a:solidFill>
-                <a:srgbClr val="FFFFFF"/>
-              </a:solidFill>
-              <a:latin typeface="Calibri"/>
-            </a:endParaRPr>
+            <a:r>
+              <a:rPr sz="600" b="0" i="0">
+                <a:solidFill>
+                  <a:srgbClr val="E8F1FB"/>
+                </a:solidFill>
+                <a:latin typeface="Calibri"/>
+              </a:rPr>
+              <a:t/>
+            </a:r>
           </a:p>
           <a:p>
             <a:pPr algn="l">
@@ -9544,12 +9314,15 @@
                 <a:spcPts val="300"/>
               </a:spcAft>
             </a:pPr>
-            <a:endParaRPr sz="1450" b="0" i="0">
-              <a:solidFill>
-                <a:srgbClr val="FFFFFF"/>
-              </a:solidFill>
-              <a:latin typeface="Calibri"/>
-            </a:endParaRPr>
+            <a:r>
+              <a:rPr sz="600" b="0" i="0">
+                <a:solidFill>
+                  <a:srgbClr val="E8F1FB"/>
+                </a:solidFill>
+                <a:latin typeface="Calibri"/>
+              </a:rPr>
+              <a:t/>
+            </a:r>
           </a:p>
           <a:p>
             <a:pPr algn="l">
@@ -9592,7 +9365,7 @@
           <a:noFill/>
         </p:spPr>
         <p:txBody>
-          <a:bodyPr wrap="square" lIns="0" tIns="0" rIns="0" bIns="0" anchor="t">
+          <a:bodyPr wrap="square" anchor="t" lIns="0" rIns="0" tIns="0" bIns="0">
             <a:spAutoFit/>
           </a:bodyPr>
           <a:lstStyle/>
@@ -9629,7 +9402,7 @@
 </file>
 
 <file path=ppt/slides/slide4.xml><?xml version="1.0" encoding="utf-8"?>
-<p:sld xmlns:a="http://schemas.openxmlformats.org/drawingml/2006/main" xmlns:r="http://schemas.openxmlformats.org/officeDocument/2006/relationships" xmlns:p="http://schemas.openxmlformats.org/presentationml/2006/main">
+<p:sld xmlns:a="http://schemas.openxmlformats.org/drawingml/2006/main" xmlns:p="http://schemas.openxmlformats.org/presentationml/2006/main" xmlns:r="http://schemas.openxmlformats.org/officeDocument/2006/relationships">
   <p:cSld>
     <p:bg>
       <p:bgPr>
@@ -9645,14 +9418,7 @@
         <p:cNvGrpSpPr/>
         <p:nvPr/>
       </p:nvGrpSpPr>
-      <p:grpSpPr>
-        <a:xfrm>
-          <a:off x="0" y="0"/>
-          <a:ext cx="0" cy="0"/>
-          <a:chOff x="0" y="0"/>
-          <a:chExt cx="0" cy="0"/>
-        </a:xfrm>
-      </p:grpSpPr>
+      <p:grpSpPr/>
       <p:sp>
         <p:nvSpPr>
           <p:cNvPr id="2" name="TextBox 1"/>
@@ -9670,7 +9436,7 @@
           <a:noFill/>
         </p:spPr>
         <p:txBody>
-          <a:bodyPr wrap="square" lIns="0" tIns="0" rIns="0" bIns="0" anchor="t">
+          <a:bodyPr wrap="square" anchor="t" lIns="0" rIns="0" tIns="0" bIns="0">
             <a:spAutoFit/>
           </a:bodyPr>
           <a:lstStyle/>
@@ -9715,7 +9481,7 @@
           <a:noFill/>
         </p:spPr>
         <p:txBody>
-          <a:bodyPr wrap="square" lIns="0" tIns="0" rIns="0" bIns="0" anchor="t">
+          <a:bodyPr wrap="square" anchor="t" lIns="0" rIns="0" tIns="0" bIns="0">
             <a:spAutoFit/>
           </a:bodyPr>
           <a:lstStyle/>
@@ -9794,7 +9560,6 @@
           <a:lstStyle/>
           <a:p>
             <a:pPr algn="ctr"/>
-            <a:endParaRPr/>
           </a:p>
         </p:txBody>
       </p:sp>
@@ -9839,7 +9604,6 @@
           <a:lstStyle/>
           <a:p>
             <a:pPr algn="ctr"/>
-            <a:endParaRPr/>
           </a:p>
         </p:txBody>
       </p:sp>
@@ -9860,7 +9624,7 @@
           <a:noFill/>
         </p:spPr>
         <p:txBody>
-          <a:bodyPr wrap="square" lIns="0" tIns="0" rIns="0" bIns="0" anchor="t">
+          <a:bodyPr wrap="square" anchor="t" lIns="0" rIns="0" tIns="0" bIns="0">
             <a:spAutoFit/>
           </a:bodyPr>
           <a:lstStyle/>
@@ -9883,7 +9647,7 @@
                 </a:solidFill>
                 <a:latin typeface="Calibri"/>
               </a:rPr>
-              <a:t>Neue Auswertung</a:t>
+              <a:t>Bedarfsanalyse</a:t>
             </a:r>
           </a:p>
         </p:txBody>
@@ -9905,7 +9669,7 @@
           <a:noFill/>
         </p:spPr>
         <p:txBody>
-          <a:bodyPr wrap="square" lIns="0" tIns="0" rIns="0" bIns="0" anchor="t">
+          <a:bodyPr wrap="square" anchor="t" lIns="0" rIns="0" tIns="0" bIns="0">
             <a:spAutoFit/>
           </a:bodyPr>
           <a:lstStyle/>
@@ -9928,7 +9692,7 @@
                 </a:solidFill>
                 <a:latin typeface="Calibri"/>
               </a:rPr>
-              <a:t>PK-/ZF-Marktanalysen starten</a:t>
+              <a:t>PK-/ZW-Marktanalysen starten</a:t>
             </a:r>
           </a:p>
         </p:txBody>
@@ -9984,7 +9748,6 @@
           <a:lstStyle/>
           <a:p>
             <a:pPr algn="ctr"/>
-            <a:endParaRPr/>
           </a:p>
         </p:txBody>
       </p:sp>
@@ -10029,7 +9792,6 @@
           <a:lstStyle/>
           <a:p>
             <a:pPr algn="ctr"/>
-            <a:endParaRPr/>
           </a:p>
         </p:txBody>
       </p:sp>
@@ -10050,7 +9812,7 @@
           <a:noFill/>
         </p:spPr>
         <p:txBody>
-          <a:bodyPr wrap="square" lIns="0" tIns="0" rIns="0" bIns="0" anchor="t">
+          <a:bodyPr wrap="square" anchor="t" lIns="0" rIns="0" tIns="0" bIns="0">
             <a:spAutoFit/>
           </a:bodyPr>
           <a:lstStyle/>
@@ -10095,7 +9857,7 @@
           <a:noFill/>
         </p:spPr>
         <p:txBody>
-          <a:bodyPr wrap="square" lIns="0" tIns="0" rIns="0" bIns="0" anchor="t">
+          <a:bodyPr wrap="square" anchor="t" lIns="0" rIns="0" tIns="0" bIns="0">
             <a:spAutoFit/>
           </a:bodyPr>
           <a:lstStyle/>
@@ -10174,7 +9936,6 @@
           <a:lstStyle/>
           <a:p>
             <a:pPr algn="ctr"/>
-            <a:endParaRPr/>
           </a:p>
         </p:txBody>
       </p:sp>
@@ -10219,7 +9980,6 @@
           <a:lstStyle/>
           <a:p>
             <a:pPr algn="ctr"/>
-            <a:endParaRPr/>
           </a:p>
         </p:txBody>
       </p:sp>
@@ -10240,7 +10000,7 @@
           <a:noFill/>
         </p:spPr>
         <p:txBody>
-          <a:bodyPr wrap="square" lIns="0" tIns="0" rIns="0" bIns="0" anchor="t">
+          <a:bodyPr wrap="square" anchor="t" lIns="0" rIns="0" tIns="0" bIns="0">
             <a:spAutoFit/>
           </a:bodyPr>
           <a:lstStyle/>
@@ -10285,7 +10045,7 @@
           <a:noFill/>
         </p:spPr>
         <p:txBody>
-          <a:bodyPr wrap="square" lIns="0" tIns="0" rIns="0" bIns="0" anchor="t">
+          <a:bodyPr wrap="square" anchor="t" lIns="0" rIns="0" tIns="0" bIns="0">
             <a:spAutoFit/>
           </a:bodyPr>
           <a:lstStyle/>
@@ -10364,7 +10124,6 @@
           <a:lstStyle/>
           <a:p>
             <a:pPr algn="ctr"/>
-            <a:endParaRPr/>
           </a:p>
         </p:txBody>
       </p:sp>
@@ -10409,7 +10168,6 @@
           <a:lstStyle/>
           <a:p>
             <a:pPr algn="ctr"/>
-            <a:endParaRPr/>
           </a:p>
         </p:txBody>
       </p:sp>
@@ -10430,7 +10188,7 @@
           <a:noFill/>
         </p:spPr>
         <p:txBody>
-          <a:bodyPr wrap="square" lIns="0" tIns="0" rIns="0" bIns="0" anchor="t">
+          <a:bodyPr wrap="square" anchor="t" lIns="0" rIns="0" tIns="0" bIns="0">
             <a:spAutoFit/>
           </a:bodyPr>
           <a:lstStyle/>
@@ -10475,7 +10233,7 @@
           <a:noFill/>
         </p:spPr>
         <p:txBody>
-          <a:bodyPr wrap="square" lIns="0" tIns="0" rIns="0" bIns="0" anchor="t">
+          <a:bodyPr wrap="square" anchor="t" lIns="0" rIns="0" tIns="0" bIns="0">
             <a:spAutoFit/>
           </a:bodyPr>
           <a:lstStyle/>
@@ -10554,7 +10312,6 @@
           <a:lstStyle/>
           <a:p>
             <a:pPr algn="ctr"/>
-            <a:endParaRPr/>
           </a:p>
         </p:txBody>
       </p:sp>
@@ -10599,7 +10356,6 @@
           <a:lstStyle/>
           <a:p>
             <a:pPr algn="ctr"/>
-            <a:endParaRPr/>
           </a:p>
         </p:txBody>
       </p:sp>
@@ -10620,7 +10376,7 @@
           <a:noFill/>
         </p:spPr>
         <p:txBody>
-          <a:bodyPr wrap="square" lIns="0" tIns="0" rIns="0" bIns="0" anchor="t">
+          <a:bodyPr wrap="square" anchor="t" lIns="0" rIns="0" tIns="0" bIns="0">
             <a:spAutoFit/>
           </a:bodyPr>
           <a:lstStyle/>
@@ -10665,7 +10421,7 @@
           <a:noFill/>
         </p:spPr>
         <p:txBody>
-          <a:bodyPr wrap="square" lIns="0" tIns="0" rIns="0" bIns="0" anchor="t">
+          <a:bodyPr wrap="square" anchor="t" lIns="0" rIns="0" tIns="0" bIns="0">
             <a:spAutoFit/>
           </a:bodyPr>
           <a:lstStyle/>
@@ -10744,7 +10500,6 @@
           <a:lstStyle/>
           <a:p>
             <a:pPr algn="ctr"/>
-            <a:endParaRPr/>
           </a:p>
         </p:txBody>
       </p:sp>
@@ -10789,7 +10544,6 @@
           <a:lstStyle/>
           <a:p>
             <a:pPr algn="ctr"/>
-            <a:endParaRPr/>
           </a:p>
         </p:txBody>
       </p:sp>
@@ -10810,7 +10564,7 @@
           <a:noFill/>
         </p:spPr>
         <p:txBody>
-          <a:bodyPr wrap="square" lIns="0" tIns="0" rIns="0" bIns="0" anchor="t">
+          <a:bodyPr wrap="square" anchor="t" lIns="0" rIns="0" tIns="0" bIns="0">
             <a:spAutoFit/>
           </a:bodyPr>
           <a:lstStyle/>
@@ -10855,7 +10609,7 @@
           <a:noFill/>
         </p:spPr>
         <p:txBody>
-          <a:bodyPr wrap="square" lIns="0" tIns="0" rIns="0" bIns="0" anchor="t">
+          <a:bodyPr wrap="square" anchor="t" lIns="0" rIns="0" tIns="0" bIns="0">
             <a:spAutoFit/>
           </a:bodyPr>
           <a:lstStyle/>
@@ -10934,7 +10688,6 @@
           <a:lstStyle/>
           <a:p>
             <a:pPr algn="ctr"/>
-            <a:endParaRPr/>
           </a:p>
         </p:txBody>
       </p:sp>
@@ -10979,7 +10732,6 @@
           <a:lstStyle/>
           <a:p>
             <a:pPr algn="ctr"/>
-            <a:endParaRPr/>
           </a:p>
         </p:txBody>
       </p:sp>
@@ -11000,7 +10752,7 @@
           <a:noFill/>
         </p:spPr>
         <p:txBody>
-          <a:bodyPr wrap="square" lIns="0" tIns="0" rIns="0" bIns="0" anchor="t">
+          <a:bodyPr wrap="square" anchor="t" lIns="0" rIns="0" tIns="0" bIns="0">
             <a:spAutoFit/>
           </a:bodyPr>
           <a:lstStyle/>
@@ -11045,7 +10797,7 @@
           <a:noFill/>
         </p:spPr>
         <p:txBody>
-          <a:bodyPr wrap="square" lIns="0" tIns="0" rIns="0" bIns="0" anchor="t">
+          <a:bodyPr wrap="square" anchor="t" lIns="0" rIns="0" tIns="0" bIns="0">
             <a:spAutoFit/>
           </a:bodyPr>
           <a:lstStyle/>
@@ -11124,7 +10876,6 @@
           <a:lstStyle/>
           <a:p>
             <a:pPr algn="ctr"/>
-            <a:endParaRPr/>
           </a:p>
         </p:txBody>
       </p:sp>
@@ -11169,7 +10920,6 @@
           <a:lstStyle/>
           <a:p>
             <a:pPr algn="ctr"/>
-            <a:endParaRPr/>
           </a:p>
         </p:txBody>
       </p:sp>
@@ -11190,7 +10940,7 @@
           <a:noFill/>
         </p:spPr>
         <p:txBody>
-          <a:bodyPr wrap="square" lIns="0" tIns="0" rIns="0" bIns="0" anchor="t">
+          <a:bodyPr wrap="square" anchor="t" lIns="0" rIns="0" tIns="0" bIns="0">
             <a:spAutoFit/>
           </a:bodyPr>
           <a:lstStyle/>
@@ -11235,7 +10985,7 @@
           <a:noFill/>
         </p:spPr>
         <p:txBody>
-          <a:bodyPr wrap="square" lIns="0" tIns="0" rIns="0" bIns="0" anchor="t">
+          <a:bodyPr wrap="square" anchor="t" lIns="0" rIns="0" tIns="0" bIns="0">
             <a:spAutoFit/>
           </a:bodyPr>
           <a:lstStyle/>
@@ -11314,7 +11064,6 @@
           <a:lstStyle/>
           <a:p>
             <a:pPr algn="ctr"/>
-            <a:endParaRPr/>
           </a:p>
         </p:txBody>
       </p:sp>
@@ -11359,7 +11108,6 @@
           <a:lstStyle/>
           <a:p>
             <a:pPr algn="ctr"/>
-            <a:endParaRPr/>
           </a:p>
         </p:txBody>
       </p:sp>
@@ -11380,7 +11128,7 @@
           <a:noFill/>
         </p:spPr>
         <p:txBody>
-          <a:bodyPr wrap="square" lIns="0" tIns="0" rIns="0" bIns="0" anchor="t">
+          <a:bodyPr wrap="square" anchor="t" lIns="0" rIns="0" tIns="0" bIns="0">
             <a:spAutoFit/>
           </a:bodyPr>
           <a:lstStyle/>
@@ -11425,7 +11173,7 @@
           <a:noFill/>
         </p:spPr>
         <p:txBody>
-          <a:bodyPr wrap="square" lIns="0" tIns="0" rIns="0" bIns="0" anchor="t">
+          <a:bodyPr wrap="square" anchor="t" lIns="0" rIns="0" tIns="0" bIns="0">
             <a:spAutoFit/>
           </a:bodyPr>
           <a:lstStyle/>
@@ -11504,7 +11252,6 @@
           <a:lstStyle/>
           <a:p>
             <a:pPr algn="ctr"/>
-            <a:endParaRPr/>
           </a:p>
         </p:txBody>
       </p:sp>
@@ -11549,7 +11296,6 @@
           <a:lstStyle/>
           <a:p>
             <a:pPr algn="ctr"/>
-            <a:endParaRPr/>
           </a:p>
         </p:txBody>
       </p:sp>
@@ -11570,7 +11316,7 @@
           <a:noFill/>
         </p:spPr>
         <p:txBody>
-          <a:bodyPr wrap="square" lIns="0" tIns="0" rIns="0" bIns="0" anchor="t">
+          <a:bodyPr wrap="square" anchor="t" lIns="0" rIns="0" tIns="0" bIns="0">
             <a:spAutoFit/>
           </a:bodyPr>
           <a:lstStyle/>
@@ -11615,7 +11361,7 @@
           <a:noFill/>
         </p:spPr>
         <p:txBody>
-          <a:bodyPr wrap="square" lIns="0" tIns="0" rIns="0" bIns="0" anchor="t">
+          <a:bodyPr wrap="square" anchor="t" lIns="0" rIns="0" tIns="0" bIns="0">
             <a:spAutoFit/>
           </a:bodyPr>
           <a:lstStyle/>
@@ -11694,7 +11440,6 @@
           <a:lstStyle/>
           <a:p>
             <a:pPr algn="ctr"/>
-            <a:endParaRPr/>
           </a:p>
         </p:txBody>
       </p:sp>
@@ -11739,7 +11484,6 @@
           <a:lstStyle/>
           <a:p>
             <a:pPr algn="ctr"/>
-            <a:endParaRPr/>
           </a:p>
         </p:txBody>
       </p:sp>
@@ -11760,7 +11504,7 @@
           <a:noFill/>
         </p:spPr>
         <p:txBody>
-          <a:bodyPr wrap="square" lIns="0" tIns="0" rIns="0" bIns="0" anchor="t">
+          <a:bodyPr wrap="square" anchor="t" lIns="0" rIns="0" tIns="0" bIns="0">
             <a:spAutoFit/>
           </a:bodyPr>
           <a:lstStyle/>
@@ -11805,7 +11549,7 @@
           <a:noFill/>
         </p:spPr>
         <p:txBody>
-          <a:bodyPr wrap="square" lIns="0" tIns="0" rIns="0" bIns="0" anchor="t">
+          <a:bodyPr wrap="square" anchor="t" lIns="0" rIns="0" tIns="0" bIns="0">
             <a:spAutoFit/>
           </a:bodyPr>
           <a:lstStyle/>
@@ -11884,7 +11628,6 @@
           <a:lstStyle/>
           <a:p>
             <a:pPr algn="ctr"/>
-            <a:endParaRPr/>
           </a:p>
         </p:txBody>
       </p:sp>
@@ -11929,7 +11672,6 @@
           <a:lstStyle/>
           <a:p>
             <a:pPr algn="ctr"/>
-            <a:endParaRPr/>
           </a:p>
         </p:txBody>
       </p:sp>
@@ -11950,7 +11692,7 @@
           <a:noFill/>
         </p:spPr>
         <p:txBody>
-          <a:bodyPr wrap="square" lIns="0" tIns="0" rIns="0" bIns="0" anchor="t">
+          <a:bodyPr wrap="square" anchor="t" lIns="0" rIns="0" tIns="0" bIns="0">
             <a:spAutoFit/>
           </a:bodyPr>
           <a:lstStyle/>
@@ -11995,7 +11737,7 @@
           <a:noFill/>
         </p:spPr>
         <p:txBody>
-          <a:bodyPr wrap="square" lIns="0" tIns="0" rIns="0" bIns="0" anchor="t">
+          <a:bodyPr wrap="square" anchor="t" lIns="0" rIns="0" tIns="0" bIns="0">
             <a:spAutoFit/>
           </a:bodyPr>
           <a:lstStyle/>
@@ -12040,7 +11782,7 @@
           <a:noFill/>
         </p:spPr>
         <p:txBody>
-          <a:bodyPr wrap="square" lIns="0" tIns="0" rIns="0" bIns="0" anchor="t">
+          <a:bodyPr wrap="square" anchor="t" lIns="0" rIns="0" tIns="0" bIns="0">
             <a:spAutoFit/>
           </a:bodyPr>
           <a:lstStyle/>
@@ -12077,7 +11819,7 @@
 </file>
 
 <file path=ppt/slides/slide5.xml><?xml version="1.0" encoding="utf-8"?>
-<p:sld xmlns:a="http://schemas.openxmlformats.org/drawingml/2006/main" xmlns:r="http://schemas.openxmlformats.org/officeDocument/2006/relationships" xmlns:p="http://schemas.openxmlformats.org/presentationml/2006/main">
+<p:sld xmlns:a="http://schemas.openxmlformats.org/drawingml/2006/main" xmlns:p="http://schemas.openxmlformats.org/presentationml/2006/main" xmlns:r="http://schemas.openxmlformats.org/officeDocument/2006/relationships">
   <p:cSld>
     <p:bg>
       <p:bgPr>
@@ -12093,14 +11835,7 @@
         <p:cNvGrpSpPr/>
         <p:nvPr/>
       </p:nvGrpSpPr>
-      <p:grpSpPr>
-        <a:xfrm>
-          <a:off x="0" y="0"/>
-          <a:ext cx="0" cy="0"/>
-          <a:chOff x="0" y="0"/>
-          <a:chExt cx="0" cy="0"/>
-        </a:xfrm>
-      </p:grpSpPr>
+      <p:grpSpPr/>
       <p:sp>
         <p:nvSpPr>
           <p:cNvPr id="2" name="TextBox 1"/>
@@ -12118,7 +11853,7 @@
           <a:noFill/>
         </p:spPr>
         <p:txBody>
-          <a:bodyPr wrap="square" lIns="0" tIns="0" rIns="0" bIns="0" anchor="t">
+          <a:bodyPr wrap="square" anchor="t" lIns="0" rIns="0" tIns="0" bIns="0">
             <a:spAutoFit/>
           </a:bodyPr>
           <a:lstStyle/>
@@ -12163,7 +11898,7 @@
           <a:noFill/>
         </p:spPr>
         <p:txBody>
-          <a:bodyPr wrap="square" lIns="0" tIns="0" rIns="0" bIns="0" anchor="t">
+          <a:bodyPr wrap="square" anchor="t" lIns="0" rIns="0" tIns="0" bIns="0">
             <a:spAutoFit/>
           </a:bodyPr>
           <a:lstStyle/>
@@ -12242,7 +11977,6 @@
           <a:lstStyle/>
           <a:p>
             <a:pPr algn="ctr"/>
-            <a:endParaRPr/>
           </a:p>
         </p:txBody>
       </p:sp>
@@ -12287,7 +12021,7 @@
           <a:noFill/>
         </p:spPr>
         <p:txBody>
-          <a:bodyPr wrap="square" lIns="0" tIns="0" rIns="0" bIns="0" anchor="t">
+          <a:bodyPr wrap="square" anchor="t" lIns="0" rIns="0" tIns="0" bIns="0">
             <a:spAutoFit/>
           </a:bodyPr>
           <a:lstStyle/>
@@ -12366,7 +12100,6 @@
           <a:lstStyle/>
           <a:p>
             <a:pPr algn="ctr"/>
-            <a:endParaRPr/>
           </a:p>
         </p:txBody>
       </p:sp>
@@ -12411,7 +12144,7 @@
           <a:noFill/>
         </p:spPr>
         <p:txBody>
-          <a:bodyPr wrap="square" lIns="0" tIns="0" rIns="0" bIns="0" anchor="t">
+          <a:bodyPr wrap="square" anchor="t" lIns="0" rIns="0" tIns="0" bIns="0">
             <a:spAutoFit/>
           </a:bodyPr>
           <a:lstStyle/>
@@ -12490,7 +12223,6 @@
           <a:lstStyle/>
           <a:p>
             <a:pPr algn="ctr"/>
-            <a:endParaRPr/>
           </a:p>
         </p:txBody>
       </p:sp>
@@ -12535,7 +12267,7 @@
           <a:noFill/>
         </p:spPr>
         <p:txBody>
-          <a:bodyPr wrap="square" lIns="0" tIns="0" rIns="0" bIns="0" anchor="t">
+          <a:bodyPr wrap="square" anchor="t" lIns="0" rIns="0" tIns="0" bIns="0">
             <a:spAutoFit/>
           </a:bodyPr>
           <a:lstStyle/>
@@ -12580,7 +12312,7 @@
           <a:noFill/>
         </p:spPr>
         <p:txBody>
-          <a:bodyPr wrap="square" lIns="0" tIns="0" rIns="0" bIns="0" anchor="t">
+          <a:bodyPr wrap="square" anchor="t" lIns="0" rIns="0" tIns="0" bIns="0">
             <a:spAutoFit/>
           </a:bodyPr>
           <a:lstStyle/>
@@ -12617,7 +12349,7 @@
 </file>
 
 <file path=ppt/slides/slide6.xml><?xml version="1.0" encoding="utf-8"?>
-<p:sld xmlns:a="http://schemas.openxmlformats.org/drawingml/2006/main" xmlns:r="http://schemas.openxmlformats.org/officeDocument/2006/relationships" xmlns:p="http://schemas.openxmlformats.org/presentationml/2006/main">
+<p:sld xmlns:a="http://schemas.openxmlformats.org/drawingml/2006/main" xmlns:p="http://schemas.openxmlformats.org/presentationml/2006/main" xmlns:r="http://schemas.openxmlformats.org/officeDocument/2006/relationships">
   <p:cSld>
     <p:bg>
       <p:bgPr>
@@ -12633,14 +12365,7 @@
         <p:cNvGrpSpPr/>
         <p:nvPr/>
       </p:nvGrpSpPr>
-      <p:grpSpPr>
-        <a:xfrm>
-          <a:off x="0" y="0"/>
-          <a:ext cx="0" cy="0"/>
-          <a:chOff x="0" y="0"/>
-          <a:chExt cx="0" cy="0"/>
-        </a:xfrm>
-      </p:grpSpPr>
+      <p:grpSpPr/>
       <p:sp>
         <p:nvSpPr>
           <p:cNvPr id="2" name="TextBox 1"/>
@@ -12658,7 +12383,7 @@
           <a:noFill/>
         </p:spPr>
         <p:txBody>
-          <a:bodyPr wrap="square" lIns="0" tIns="0" rIns="0" bIns="0" anchor="t">
+          <a:bodyPr wrap="square" anchor="t" lIns="0" rIns="0" tIns="0" bIns="0">
             <a:spAutoFit/>
           </a:bodyPr>
           <a:lstStyle/>
@@ -12737,7 +12462,6 @@
           <a:lstStyle/>
           <a:p>
             <a:pPr algn="ctr"/>
-            <a:endParaRPr/>
           </a:p>
         </p:txBody>
       </p:sp>
@@ -12784,7 +12508,6 @@
           <a:lstStyle/>
           <a:p>
             <a:pPr algn="ctr"/>
-            <a:endParaRPr/>
           </a:p>
         </p:txBody>
       </p:sp>
@@ -12829,7 +12552,6 @@
           <a:lstStyle/>
           <a:p>
             <a:pPr algn="ctr"/>
-            <a:endParaRPr/>
           </a:p>
         </p:txBody>
       </p:sp>
@@ -12850,7 +12572,7 @@
           <a:noFill/>
         </p:spPr>
         <p:txBody>
-          <a:bodyPr wrap="square" lIns="0" tIns="0" rIns="0" bIns="0" anchor="ctr">
+          <a:bodyPr wrap="square" anchor="ctr" lIns="0" rIns="0" tIns="0" bIns="0">
             <a:spAutoFit/>
           </a:bodyPr>
           <a:lstStyle/>
@@ -12887,7 +12609,7 @@
         <p:spPr>
           <a:xfrm>
             <a:off x="1097280" y="2697480"/>
-            <a:ext cx="2871216" cy="1641860"/>
+            <a:ext cx="2871216" cy="3108960"/>
           </a:xfrm>
           <a:prstGeom prst="rect">
             <a:avLst/>
@@ -12895,7 +12617,7 @@
           <a:noFill/>
         </p:spPr>
         <p:txBody>
-          <a:bodyPr wrap="square" lIns="0" tIns="0" rIns="0" bIns="0">
+          <a:bodyPr wrap="square" lIns="0" rIns="0" tIns="0" bIns="0">
             <a:spAutoFit/>
           </a:bodyPr>
           <a:lstStyle/>
@@ -12909,7 +12631,7 @@
               </a:spcAft>
             </a:pPr>
             <a:r>
-              <a:rPr sz="1400" b="1" dirty="0">
+              <a:rPr b="1" sz="1400">
                 <a:solidFill>
                   <a:srgbClr val="0B4A86"/>
                 </a:solidFill>
@@ -12918,187 +12640,70 @@
               <a:t>—  </a:t>
             </a:r>
             <a:r>
-              <a:rPr sz="1400" dirty="0">
+              <a:rPr sz="1400">
                 <a:solidFill>
                   <a:srgbClr val="1B2633"/>
                 </a:solidFill>
                 <a:latin typeface="Calibri"/>
               </a:rPr>
-              <a:t>PK- und Z</a:t>
-            </a:r>
-            <a:r>
-              <a:rPr lang="de-DE" sz="1400" dirty="0">
+              <a:t>PK- und ZF-Auswertungen auf Knopfdruck</a:t>
+            </a:r>
+          </a:p>
+          <a:p>
+            <a:pPr>
+              <a:lnSpc>
+                <a:spcPct val="108000"/>
+              </a:lnSpc>
+              <a:spcAft>
+                <a:spcPts val="1000"/>
+              </a:spcAft>
+            </a:pPr>
+            <a:r>
+              <a:rPr b="1" sz="1400">
+                <a:solidFill>
+                  <a:srgbClr val="0B4A86"/>
+                </a:solidFill>
+                <a:latin typeface="Calibri"/>
+              </a:rPr>
+              <a:t>—  </a:t>
+            </a:r>
+            <a:r>
+              <a:rPr sz="1400">
                 <a:solidFill>
                   <a:srgbClr val="1B2633"/>
                 </a:solidFill>
                 <a:latin typeface="Calibri"/>
               </a:rPr>
-              <a:t>W</a:t>
-            </a:r>
-            <a:r>
-              <a:rPr sz="1400" dirty="0">
+              <a:t>Produktchancen &amp; Abweichungs-Analyse</a:t>
+            </a:r>
+          </a:p>
+          <a:p>
+            <a:pPr>
+              <a:lnSpc>
+                <a:spcPct val="108000"/>
+              </a:lnSpc>
+              <a:spcAft>
+                <a:spcPts val="1000"/>
+              </a:spcAft>
+            </a:pPr>
+            <a:r>
+              <a:rPr b="1" sz="1400">
+                <a:solidFill>
+                  <a:srgbClr val="0B4A86"/>
+                </a:solidFill>
+                <a:latin typeface="Calibri"/>
+              </a:rPr>
+              <a:t>—  </a:t>
+            </a:r>
+            <a:r>
+              <a:rPr sz="1400">
                 <a:solidFill>
                   <a:srgbClr val="1B2633"/>
                 </a:solidFill>
                 <a:latin typeface="Calibri"/>
               </a:rPr>
-              <a:t>-</a:t>
-            </a:r>
-            <a:r>
-              <a:rPr sz="1400" dirty="0" err="1">
-                <a:solidFill>
-                  <a:srgbClr val="1B2633"/>
-                </a:solidFill>
-                <a:latin typeface="Calibri"/>
-              </a:rPr>
-              <a:t>Auswertungen</a:t>
-            </a:r>
-            <a:r>
-              <a:rPr sz="1400" dirty="0">
-                <a:solidFill>
-                  <a:srgbClr val="1B2633"/>
-                </a:solidFill>
-                <a:latin typeface="Calibri"/>
-              </a:rPr>
-              <a:t> auf </a:t>
-            </a:r>
-            <a:r>
-              <a:rPr sz="1400" dirty="0" err="1">
-                <a:solidFill>
-                  <a:srgbClr val="1B2633"/>
-                </a:solidFill>
-                <a:latin typeface="Calibri"/>
-              </a:rPr>
-              <a:t>Knopfdruck</a:t>
-            </a:r>
-            <a:endParaRPr sz="1400" dirty="0">
-              <a:solidFill>
-                <a:srgbClr val="1B2633"/>
-              </a:solidFill>
-              <a:latin typeface="Calibri"/>
-            </a:endParaRPr>
-          </a:p>
-          <a:p>
-            <a:pPr>
-              <a:lnSpc>
-                <a:spcPct val="108000"/>
-              </a:lnSpc>
-              <a:spcAft>
-                <a:spcPts val="1000"/>
-              </a:spcAft>
-            </a:pPr>
-            <a:r>
-              <a:rPr sz="1400" b="1" dirty="0">
-                <a:solidFill>
-                  <a:srgbClr val="0B4A86"/>
-                </a:solidFill>
-                <a:latin typeface="Calibri"/>
-              </a:rPr>
-              <a:t>—  </a:t>
-            </a:r>
-            <a:r>
-              <a:rPr sz="1400" dirty="0" err="1">
-                <a:solidFill>
-                  <a:srgbClr val="1B2633"/>
-                </a:solidFill>
-                <a:latin typeface="Calibri"/>
-              </a:rPr>
-              <a:t>Produktchancen</a:t>
-            </a:r>
-            <a:r>
-              <a:rPr sz="1400" dirty="0">
-                <a:solidFill>
-                  <a:srgbClr val="1B2633"/>
-                </a:solidFill>
-                <a:latin typeface="Calibri"/>
-              </a:rPr>
-              <a:t> &amp; </a:t>
-            </a:r>
-            <a:r>
-              <a:rPr sz="1400" dirty="0" err="1">
-                <a:solidFill>
-                  <a:srgbClr val="1B2633"/>
-                </a:solidFill>
-                <a:latin typeface="Calibri"/>
-              </a:rPr>
-              <a:t>Abweichungs-Analyse</a:t>
-            </a:r>
-            <a:endParaRPr sz="1400" dirty="0">
-              <a:solidFill>
-                <a:srgbClr val="1B2633"/>
-              </a:solidFill>
-              <a:latin typeface="Calibri"/>
-            </a:endParaRPr>
-          </a:p>
-          <a:p>
-            <a:pPr>
-              <a:lnSpc>
-                <a:spcPct val="108000"/>
-              </a:lnSpc>
-              <a:spcAft>
-                <a:spcPts val="1000"/>
-              </a:spcAft>
-            </a:pPr>
-            <a:r>
-              <a:rPr sz="1400" b="1" dirty="0">
-                <a:solidFill>
-                  <a:srgbClr val="0B4A86"/>
-                </a:solidFill>
-                <a:latin typeface="Calibri"/>
-              </a:rPr>
-              <a:t>—  </a:t>
-            </a:r>
-            <a:r>
-              <a:rPr sz="1400" dirty="0" err="1">
-                <a:solidFill>
-                  <a:srgbClr val="1B2633"/>
-                </a:solidFill>
-                <a:latin typeface="Calibri"/>
-              </a:rPr>
-              <a:t>Ergebnisse</a:t>
-            </a:r>
-            <a:r>
-              <a:rPr sz="1400" dirty="0">
-                <a:solidFill>
-                  <a:srgbClr val="1B2633"/>
-                </a:solidFill>
-                <a:latin typeface="Calibri"/>
-              </a:rPr>
-              <a:t> </a:t>
-            </a:r>
-            <a:r>
-              <a:rPr sz="1400" dirty="0" err="1">
-                <a:solidFill>
-                  <a:srgbClr val="1B2633"/>
-                </a:solidFill>
-                <a:latin typeface="Calibri"/>
-              </a:rPr>
-              <a:t>speichern</a:t>
-            </a:r>
-            <a:r>
-              <a:rPr sz="1400" dirty="0">
-                <a:solidFill>
-                  <a:srgbClr val="1B2633"/>
-                </a:solidFill>
-                <a:latin typeface="Calibri"/>
-              </a:rPr>
-              <a:t> und </a:t>
-            </a:r>
-            <a:r>
-              <a:rPr sz="1400" dirty="0" err="1">
-                <a:solidFill>
-                  <a:srgbClr val="1B2633"/>
-                </a:solidFill>
-                <a:latin typeface="Calibri"/>
-              </a:rPr>
-              <a:t>wiederfinden</a:t>
-            </a:r>
-            <a:endParaRPr sz="1400" dirty="0">
-              <a:solidFill>
-                <a:srgbClr val="1B2633"/>
-              </a:solidFill>
-              <a:latin typeface="Calibri"/>
-            </a:endParaRPr>
+              <a:t>Ergebnisse speichern und wiederfinden</a:t>
+            </a:r>
           </a:p>
         </p:txBody>
       </p:sp>
@@ -13153,7 +12758,6 @@
           <a:lstStyle/>
           <a:p>
             <a:pPr algn="ctr"/>
-            <a:endParaRPr/>
           </a:p>
         </p:txBody>
       </p:sp>
@@ -13200,7 +12804,6 @@
           <a:lstStyle/>
           <a:p>
             <a:pPr algn="ctr"/>
-            <a:endParaRPr/>
           </a:p>
         </p:txBody>
       </p:sp>
@@ -13245,7 +12848,6 @@
           <a:lstStyle/>
           <a:p>
             <a:pPr algn="ctr"/>
-            <a:endParaRPr/>
           </a:p>
         </p:txBody>
       </p:sp>
@@ -13266,7 +12868,7 @@
           <a:noFill/>
         </p:spPr>
         <p:txBody>
-          <a:bodyPr wrap="square" lIns="0" tIns="0" rIns="0" bIns="0" anchor="ctr">
+          <a:bodyPr wrap="square" anchor="ctr" lIns="0" rIns="0" tIns="0" bIns="0">
             <a:spAutoFit/>
           </a:bodyPr>
           <a:lstStyle/>
@@ -13303,7 +12905,7 @@
         <p:spPr>
           <a:xfrm>
             <a:off x="4764024" y="2697480"/>
-            <a:ext cx="2871216" cy="1641860"/>
+            <a:ext cx="2871216" cy="3108960"/>
           </a:xfrm>
           <a:prstGeom prst="rect">
             <a:avLst/>
@@ -13311,7 +12913,7 @@
           <a:noFill/>
         </p:spPr>
         <p:txBody>
-          <a:bodyPr wrap="square" lIns="0" tIns="0" rIns="0" bIns="0">
+          <a:bodyPr wrap="square" lIns="0" rIns="0" tIns="0" bIns="0">
             <a:spAutoFit/>
           </a:bodyPr>
           <a:lstStyle/>
@@ -13325,7 +12927,7 @@
               </a:spcAft>
             </a:pPr>
             <a:r>
-              <a:rPr sz="1400" b="1" dirty="0">
+              <a:rPr b="1" sz="1400">
                 <a:solidFill>
                   <a:srgbClr val="6B4FB3"/>
                 </a:solidFill>
@@ -13334,250 +12936,70 @@
               <a:t>—  </a:t>
             </a:r>
             <a:r>
-              <a:rPr sz="1400" dirty="0">
+              <a:rPr sz="1400">
                 <a:solidFill>
                   <a:srgbClr val="1B2633"/>
                 </a:solidFill>
                 <a:latin typeface="Calibri"/>
               </a:rPr>
-              <a:t>NMG-</a:t>
-            </a:r>
-            <a:r>
-              <a:rPr sz="1400" dirty="0" err="1">
+              <a:t>NMG-Rabatte zentral pflegen – mit Verlauf</a:t>
+            </a:r>
+          </a:p>
+          <a:p>
+            <a:pPr>
+              <a:lnSpc>
+                <a:spcPct val="108000"/>
+              </a:lnSpc>
+              <a:spcAft>
+                <a:spcPts val="1000"/>
+              </a:spcAft>
+            </a:pPr>
+            <a:r>
+              <a:rPr b="1" sz="1400">
+                <a:solidFill>
+                  <a:srgbClr val="6B4FB3"/>
+                </a:solidFill>
+                <a:latin typeface="Calibri"/>
+              </a:rPr>
+              <a:t>—  </a:t>
+            </a:r>
+            <a:r>
+              <a:rPr sz="1400">
                 <a:solidFill>
                   <a:srgbClr val="1B2633"/>
                 </a:solidFill>
                 <a:latin typeface="Calibri"/>
               </a:rPr>
-              <a:t>Rabatte</a:t>
-            </a:r>
-            <a:r>
-              <a:rPr sz="1400" dirty="0">
+              <a:t>Kundenindividuelle PK-Konditionen</a:t>
+            </a:r>
+          </a:p>
+          <a:p>
+            <a:pPr>
+              <a:lnSpc>
+                <a:spcPct val="108000"/>
+              </a:lnSpc>
+              <a:spcAft>
+                <a:spcPts val="1000"/>
+              </a:spcAft>
+            </a:pPr>
+            <a:r>
+              <a:rPr b="1" sz="1400">
+                <a:solidFill>
+                  <a:srgbClr val="6B4FB3"/>
+                </a:solidFill>
+                <a:latin typeface="Calibri"/>
+              </a:rPr>
+              <a:t>—  </a:t>
+            </a:r>
+            <a:r>
+              <a:rPr sz="1400">
                 <a:solidFill>
                   <a:srgbClr val="1B2633"/>
                 </a:solidFill>
                 <a:latin typeface="Calibri"/>
               </a:rPr>
-              <a:t> </a:t>
-            </a:r>
-            <a:r>
-              <a:rPr sz="1400" dirty="0" err="1">
-                <a:solidFill>
-                  <a:srgbClr val="1B2633"/>
-                </a:solidFill>
-                <a:latin typeface="Calibri"/>
-              </a:rPr>
-              <a:t>zentral</a:t>
-            </a:r>
-            <a:r>
-              <a:rPr sz="1400" dirty="0">
-                <a:solidFill>
-                  <a:srgbClr val="1B2633"/>
-                </a:solidFill>
-                <a:latin typeface="Calibri"/>
-              </a:rPr>
-              <a:t> </a:t>
-            </a:r>
-            <a:r>
-              <a:rPr sz="1400" dirty="0" err="1">
-                <a:solidFill>
-                  <a:srgbClr val="1B2633"/>
-                </a:solidFill>
-                <a:latin typeface="Calibri"/>
-              </a:rPr>
-              <a:t>pflegen</a:t>
-            </a:r>
-            <a:r>
-              <a:rPr sz="1400" dirty="0">
-                <a:solidFill>
-                  <a:srgbClr val="1B2633"/>
-                </a:solidFill>
-                <a:latin typeface="Calibri"/>
-              </a:rPr>
-              <a:t> – </a:t>
-            </a:r>
-            <a:r>
-              <a:rPr sz="1400" dirty="0" err="1">
-                <a:solidFill>
-                  <a:srgbClr val="1B2633"/>
-                </a:solidFill>
-                <a:latin typeface="Calibri"/>
-              </a:rPr>
-              <a:t>mit</a:t>
-            </a:r>
-            <a:r>
-              <a:rPr sz="1400" dirty="0">
-                <a:solidFill>
-                  <a:srgbClr val="1B2633"/>
-                </a:solidFill>
-                <a:latin typeface="Calibri"/>
-              </a:rPr>
-              <a:t> </a:t>
-            </a:r>
-            <a:r>
-              <a:rPr sz="1400" dirty="0" err="1">
-                <a:solidFill>
-                  <a:srgbClr val="1B2633"/>
-                </a:solidFill>
-                <a:latin typeface="Calibri"/>
-              </a:rPr>
-              <a:t>Verlauf</a:t>
-            </a:r>
-            <a:endParaRPr sz="1400" dirty="0">
-              <a:solidFill>
-                <a:srgbClr val="1B2633"/>
-              </a:solidFill>
-              <a:latin typeface="Calibri"/>
-            </a:endParaRPr>
-          </a:p>
-          <a:p>
-            <a:pPr>
-              <a:lnSpc>
-                <a:spcPct val="108000"/>
-              </a:lnSpc>
-              <a:spcAft>
-                <a:spcPts val="1000"/>
-              </a:spcAft>
-            </a:pPr>
-            <a:r>
-              <a:rPr sz="1400" b="1" dirty="0">
-                <a:solidFill>
-                  <a:srgbClr val="6B4FB3"/>
-                </a:solidFill>
-                <a:latin typeface="Calibri"/>
-              </a:rPr>
-              <a:t>—  </a:t>
-            </a:r>
-            <a:r>
-              <a:rPr sz="1400" dirty="0" err="1">
-                <a:solidFill>
-                  <a:srgbClr val="1B2633"/>
-                </a:solidFill>
-                <a:latin typeface="Calibri"/>
-              </a:rPr>
-              <a:t>Kundenindividuelle</a:t>
-            </a:r>
-            <a:r>
-              <a:rPr sz="1400" dirty="0">
-                <a:solidFill>
-                  <a:srgbClr val="1B2633"/>
-                </a:solidFill>
-                <a:latin typeface="Calibri"/>
-              </a:rPr>
-              <a:t> P</a:t>
-            </a:r>
-            <a:r>
-              <a:rPr lang="de-DE" sz="1400" dirty="0" err="1">
-                <a:solidFill>
-                  <a:srgbClr val="1B2633"/>
-                </a:solidFill>
-                <a:latin typeface="Calibri"/>
-              </a:rPr>
-              <a:t>artnerk</a:t>
-            </a:r>
-            <a:r>
-              <a:rPr sz="1400" dirty="0" err="1">
-                <a:solidFill>
-                  <a:srgbClr val="1B2633"/>
-                </a:solidFill>
-                <a:latin typeface="Calibri"/>
-              </a:rPr>
-              <a:t>onditionen</a:t>
-            </a:r>
-            <a:endParaRPr sz="1400" dirty="0">
-              <a:solidFill>
-                <a:srgbClr val="1B2633"/>
-              </a:solidFill>
-              <a:latin typeface="Calibri"/>
-            </a:endParaRPr>
-          </a:p>
-          <a:p>
-            <a:pPr>
-              <a:lnSpc>
-                <a:spcPct val="108000"/>
-              </a:lnSpc>
-              <a:spcAft>
-                <a:spcPts val="1000"/>
-              </a:spcAft>
-            </a:pPr>
-            <a:r>
-              <a:rPr sz="1400" b="1" dirty="0">
-                <a:solidFill>
-                  <a:srgbClr val="6B4FB3"/>
-                </a:solidFill>
-                <a:latin typeface="Calibri"/>
-              </a:rPr>
-              <a:t>—  </a:t>
-            </a:r>
-            <a:r>
-              <a:rPr sz="1400" dirty="0" err="1">
-                <a:solidFill>
-                  <a:srgbClr val="1B2633"/>
-                </a:solidFill>
-                <a:latin typeface="Calibri"/>
-              </a:rPr>
-              <a:t>Rabatt</a:t>
-            </a:r>
-            <a:r>
-              <a:rPr sz="1400" dirty="0">
-                <a:solidFill>
-                  <a:srgbClr val="1B2633"/>
-                </a:solidFill>
-                <a:latin typeface="Calibri"/>
-              </a:rPr>
-              <a:t>-Kaskade </a:t>
-            </a:r>
-            <a:r>
-              <a:rPr sz="1400" dirty="0" err="1">
-                <a:solidFill>
-                  <a:srgbClr val="1B2633"/>
-                </a:solidFill>
-                <a:latin typeface="Calibri"/>
-              </a:rPr>
-              <a:t>automatisch</a:t>
-            </a:r>
-            <a:r>
-              <a:rPr sz="1400" dirty="0">
-                <a:solidFill>
-                  <a:srgbClr val="1B2633"/>
-                </a:solidFill>
-                <a:latin typeface="Calibri"/>
-              </a:rPr>
-              <a:t> </a:t>
-            </a:r>
-            <a:r>
-              <a:rPr sz="1400" dirty="0" err="1">
-                <a:solidFill>
-                  <a:srgbClr val="1B2633"/>
-                </a:solidFill>
-                <a:latin typeface="Calibri"/>
-              </a:rPr>
-              <a:t>im</a:t>
-            </a:r>
-            <a:r>
-              <a:rPr sz="1400" dirty="0">
-                <a:solidFill>
-                  <a:srgbClr val="1B2633"/>
-                </a:solidFill>
-                <a:latin typeface="Calibri"/>
-              </a:rPr>
-              <a:t> </a:t>
-            </a:r>
-            <a:r>
-              <a:rPr sz="1400" dirty="0" err="1">
-                <a:solidFill>
-                  <a:srgbClr val="1B2633"/>
-                </a:solidFill>
-                <a:latin typeface="Calibri"/>
-              </a:rPr>
-              <a:t>Verkauf</a:t>
-            </a:r>
-            <a:endParaRPr sz="1400" dirty="0">
-              <a:solidFill>
-                <a:srgbClr val="1B2633"/>
-              </a:solidFill>
-              <a:latin typeface="Calibri"/>
-            </a:endParaRPr>
+              <a:t>Rabatt-Kaskade automatisch im Verkauf</a:t>
+            </a:r>
           </a:p>
         </p:txBody>
       </p:sp>
@@ -13632,7 +13054,6 @@
           <a:lstStyle/>
           <a:p>
             <a:pPr algn="ctr"/>
-            <a:endParaRPr/>
           </a:p>
         </p:txBody>
       </p:sp>
@@ -13679,7 +13100,6 @@
           <a:lstStyle/>
           <a:p>
             <a:pPr algn="ctr"/>
-            <a:endParaRPr/>
           </a:p>
         </p:txBody>
       </p:sp>
@@ -13724,7 +13144,6 @@
           <a:lstStyle/>
           <a:p>
             <a:pPr algn="ctr"/>
-            <a:endParaRPr/>
           </a:p>
         </p:txBody>
       </p:sp>
@@ -13745,7 +13164,7 @@
           <a:noFill/>
         </p:spPr>
         <p:txBody>
-          <a:bodyPr wrap="square" lIns="0" tIns="0" rIns="0" bIns="0" anchor="ctr">
+          <a:bodyPr wrap="square" anchor="ctr" lIns="0" rIns="0" tIns="0" bIns="0">
             <a:spAutoFit/>
           </a:bodyPr>
           <a:lstStyle/>
@@ -13790,7 +13209,7 @@
           <a:noFill/>
         </p:spPr>
         <p:txBody>
-          <a:bodyPr wrap="square" lIns="0" tIns="0" rIns="0" bIns="0">
+          <a:bodyPr wrap="square" lIns="0" rIns="0" tIns="0" bIns="0">
             <a:spAutoFit/>
           </a:bodyPr>
           <a:lstStyle/>
@@ -13804,7 +13223,7 @@
               </a:spcAft>
             </a:pPr>
             <a:r>
-              <a:rPr sz="1400" b="1">
+              <a:rPr b="1" sz="1400">
                 <a:solidFill>
                   <a:srgbClr val="11823B"/>
                 </a:solidFill>
@@ -13832,7 +13251,7 @@
               </a:spcAft>
             </a:pPr>
             <a:r>
-              <a:rPr sz="1400" b="1">
+              <a:rPr b="1" sz="1400">
                 <a:solidFill>
                   <a:srgbClr val="11823B"/>
                 </a:solidFill>
@@ -13860,7 +13279,7 @@
               </a:spcAft>
             </a:pPr>
             <a:r>
-              <a:rPr sz="1400" b="1">
+              <a:rPr b="1" sz="1400">
                 <a:solidFill>
                   <a:srgbClr val="11823B"/>
                 </a:solidFill>
@@ -13897,7 +13316,7 @@
           <a:noFill/>
         </p:spPr>
         <p:txBody>
-          <a:bodyPr wrap="square" lIns="0" tIns="0" rIns="0" bIns="0" anchor="t">
+          <a:bodyPr wrap="square" anchor="t" lIns="0" rIns="0" tIns="0" bIns="0">
             <a:spAutoFit/>
           </a:bodyPr>
           <a:lstStyle/>
@@ -13934,7 +13353,7 @@
 </file>
 
 <file path=ppt/slides/slide7.xml><?xml version="1.0" encoding="utf-8"?>
-<p:sld xmlns:a="http://schemas.openxmlformats.org/drawingml/2006/main" xmlns:r="http://schemas.openxmlformats.org/officeDocument/2006/relationships" xmlns:p="http://schemas.openxmlformats.org/presentationml/2006/main">
+<p:sld xmlns:a="http://schemas.openxmlformats.org/drawingml/2006/main" xmlns:p="http://schemas.openxmlformats.org/presentationml/2006/main" xmlns:r="http://schemas.openxmlformats.org/officeDocument/2006/relationships">
   <p:cSld>
     <p:bg>
       <p:bgPr>
@@ -13950,14 +13369,7 @@
         <p:cNvGrpSpPr/>
         <p:nvPr/>
       </p:nvGrpSpPr>
-      <p:grpSpPr>
-        <a:xfrm>
-          <a:off x="0" y="0"/>
-          <a:ext cx="0" cy="0"/>
-          <a:chOff x="0" y="0"/>
-          <a:chExt cx="0" cy="0"/>
-        </a:xfrm>
-      </p:grpSpPr>
+      <p:grpSpPr/>
       <p:sp>
         <p:nvSpPr>
           <p:cNvPr id="2" name="Rectangle 1"/>
@@ -13999,7 +13411,6 @@
           <a:lstStyle/>
           <a:p>
             <a:pPr algn="ctr"/>
-            <a:endParaRPr/>
           </a:p>
         </p:txBody>
       </p:sp>
@@ -14046,7 +13457,6 @@
           <a:lstStyle/>
           <a:p>
             <a:pPr algn="ctr"/>
-            <a:endParaRPr/>
           </a:p>
         </p:txBody>
       </p:sp>
@@ -14067,7 +13477,7 @@
           <a:noFill/>
         </p:spPr>
         <p:txBody>
-          <a:bodyPr wrap="square" lIns="0" tIns="0" rIns="0" bIns="0" anchor="ctr">
+          <a:bodyPr wrap="square" anchor="ctr" lIns="0" rIns="0" tIns="0" bIns="0">
             <a:spAutoFit/>
           </a:bodyPr>
           <a:lstStyle/>
@@ -14112,7 +13522,7 @@
           <a:noFill/>
         </p:spPr>
         <p:txBody>
-          <a:bodyPr wrap="square" lIns="0" tIns="0" rIns="0" bIns="0" anchor="t">
+          <a:bodyPr wrap="square" anchor="t" lIns="0" rIns="0" tIns="0" bIns="0">
             <a:spAutoFit/>
           </a:bodyPr>
           <a:lstStyle/>
@@ -14183,7 +13593,6 @@
           <a:lstStyle/>
           <a:p>
             <a:pPr algn="ctr"/>
-            <a:endParaRPr/>
           </a:p>
         </p:txBody>
       </p:sp>
@@ -14204,7 +13613,7 @@
           <a:noFill/>
         </p:spPr>
         <p:txBody>
-          <a:bodyPr wrap="square" lIns="0" tIns="0" rIns="0" bIns="0" anchor="ctr">
+          <a:bodyPr wrap="square" anchor="ctr" lIns="0" rIns="0" tIns="0" bIns="0">
             <a:spAutoFit/>
           </a:bodyPr>
           <a:lstStyle/>
@@ -14249,7 +13658,7 @@
           <a:noFill/>
         </p:spPr>
         <p:txBody>
-          <a:bodyPr wrap="square" lIns="0" tIns="0" rIns="0" bIns="0" anchor="t">
+          <a:bodyPr wrap="square" anchor="t" lIns="0" rIns="0" tIns="0" bIns="0">
             <a:spAutoFit/>
           </a:bodyPr>
           <a:lstStyle/>
@@ -14342,7 +13751,6 @@
           <a:lstStyle/>
           <a:p>
             <a:pPr algn="ctr"/>
-            <a:endParaRPr/>
           </a:p>
         </p:txBody>
       </p:sp>
@@ -14363,7 +13771,7 @@
           <a:noFill/>
         </p:spPr>
         <p:txBody>
-          <a:bodyPr wrap="square" lIns="0" tIns="0" rIns="0" bIns="0" anchor="ctr">
+          <a:bodyPr wrap="square" anchor="ctr" lIns="0" rIns="0" tIns="0" bIns="0">
             <a:spAutoFit/>
           </a:bodyPr>
           <a:lstStyle/>
@@ -14408,7 +13816,7 @@
           <a:noFill/>
         </p:spPr>
         <p:txBody>
-          <a:bodyPr wrap="square" lIns="0" tIns="0" rIns="0" bIns="0" anchor="t">
+          <a:bodyPr wrap="square" anchor="t" lIns="0" rIns="0" tIns="0" bIns="0">
             <a:spAutoFit/>
           </a:bodyPr>
           <a:lstStyle/>
@@ -14501,7 +13909,6 @@
           <a:lstStyle/>
           <a:p>
             <a:pPr algn="ctr"/>
-            <a:endParaRPr/>
           </a:p>
         </p:txBody>
       </p:sp>
@@ -14522,7 +13929,7 @@
           <a:noFill/>
         </p:spPr>
         <p:txBody>
-          <a:bodyPr wrap="square" lIns="0" tIns="0" rIns="0" bIns="0" anchor="ctr">
+          <a:bodyPr wrap="square" anchor="ctr" lIns="0" rIns="0" tIns="0" bIns="0">
             <a:spAutoFit/>
           </a:bodyPr>
           <a:lstStyle/>
@@ -14567,7 +13974,7 @@
           <a:noFill/>
         </p:spPr>
         <p:txBody>
-          <a:bodyPr wrap="square" lIns="0" tIns="0" rIns="0" bIns="0" anchor="t">
+          <a:bodyPr wrap="square" anchor="t" lIns="0" rIns="0" tIns="0" bIns="0">
             <a:spAutoFit/>
           </a:bodyPr>
           <a:lstStyle/>
@@ -14634,7 +14041,7 @@
           <a:noFill/>
         </p:spPr>
         <p:txBody>
-          <a:bodyPr wrap="square" lIns="0" tIns="0" rIns="0" bIns="0" anchor="t">
+          <a:bodyPr wrap="square" anchor="t" lIns="0" rIns="0" tIns="0" bIns="0">
             <a:spAutoFit/>
           </a:bodyPr>
           <a:lstStyle/>
@@ -14722,7 +14129,6 @@
           <a:lstStyle/>
           <a:p>
             <a:pPr algn="ctr"/>
-            <a:endParaRPr/>
           </a:p>
         </p:txBody>
       </p:sp>
@@ -14767,7 +14173,7 @@
           <a:noFill/>
         </p:spPr>
         <p:txBody>
-          <a:bodyPr wrap="square" lIns="0" tIns="0" rIns="0" bIns="0" anchor="t">
+          <a:bodyPr wrap="square" anchor="t" lIns="0" rIns="0" tIns="0" bIns="0">
             <a:spAutoFit/>
           </a:bodyPr>
           <a:lstStyle/>
@@ -14812,7 +14218,7 @@
           <a:noFill/>
         </p:spPr>
         <p:txBody>
-          <a:bodyPr wrap="square" lIns="0" tIns="0" rIns="0" bIns="0" anchor="t">
+          <a:bodyPr wrap="square" anchor="t" lIns="0" rIns="0" tIns="0" bIns="0">
             <a:spAutoFit/>
           </a:bodyPr>
           <a:lstStyle/>
@@ -14849,7 +14255,7 @@
 </file>
 
 <file path=ppt/slides/slide8.xml><?xml version="1.0" encoding="utf-8"?>
-<p:sld xmlns:a="http://schemas.openxmlformats.org/drawingml/2006/main" xmlns:r="http://schemas.openxmlformats.org/officeDocument/2006/relationships" xmlns:p="http://schemas.openxmlformats.org/presentationml/2006/main">
+<p:sld xmlns:a="http://schemas.openxmlformats.org/drawingml/2006/main" xmlns:p="http://schemas.openxmlformats.org/presentationml/2006/main" xmlns:r="http://schemas.openxmlformats.org/officeDocument/2006/relationships">
   <p:cSld>
     <p:bg>
       <p:bgPr>
@@ -14865,14 +14271,7 @@
         <p:cNvGrpSpPr/>
         <p:nvPr/>
       </p:nvGrpSpPr>
-      <p:grpSpPr>
-        <a:xfrm>
-          <a:off x="0" y="0"/>
-          <a:ext cx="0" cy="0"/>
-          <a:chOff x="0" y="0"/>
-          <a:chExt cx="0" cy="0"/>
-        </a:xfrm>
-      </p:grpSpPr>
+      <p:grpSpPr/>
       <p:sp>
         <p:nvSpPr>
           <p:cNvPr id="2" name="TextBox 1"/>
@@ -14890,7 +14289,7 @@
           <a:noFill/>
         </p:spPr>
         <p:txBody>
-          <a:bodyPr wrap="square" lIns="0" tIns="0" rIns="0" bIns="0" anchor="t">
+          <a:bodyPr wrap="square" anchor="t" lIns="0" rIns="0" tIns="0" bIns="0">
             <a:spAutoFit/>
           </a:bodyPr>
           <a:lstStyle/>
@@ -14969,7 +14368,6 @@
           <a:lstStyle/>
           <a:p>
             <a:pPr algn="ctr"/>
-            <a:endParaRPr/>
           </a:p>
         </p:txBody>
       </p:sp>
@@ -15016,7 +14414,6 @@
           <a:lstStyle/>
           <a:p>
             <a:pPr algn="ctr"/>
-            <a:endParaRPr/>
           </a:p>
         </p:txBody>
       </p:sp>
@@ -15037,7 +14434,7 @@
           <a:noFill/>
         </p:spPr>
         <p:txBody>
-          <a:bodyPr wrap="square" lIns="0" tIns="0" rIns="0" bIns="0" anchor="ctr">
+          <a:bodyPr wrap="square" anchor="ctr" lIns="0" rIns="0" tIns="0" bIns="0">
             <a:spAutoFit/>
           </a:bodyPr>
           <a:lstStyle/>
@@ -15082,7 +14479,7 @@
           <a:noFill/>
         </p:spPr>
         <p:txBody>
-          <a:bodyPr wrap="square" lIns="0" tIns="0" rIns="0" bIns="0" anchor="t">
+          <a:bodyPr wrap="square" anchor="t" lIns="0" rIns="0" tIns="0" bIns="0">
             <a:spAutoFit/>
           </a:bodyPr>
           <a:lstStyle/>
@@ -15127,7 +14524,7 @@
           <a:noFill/>
         </p:spPr>
         <p:txBody>
-          <a:bodyPr wrap="square" lIns="0" tIns="0" rIns="0" bIns="0" anchor="t">
+          <a:bodyPr wrap="square" anchor="t" lIns="0" rIns="0" tIns="0" bIns="0">
             <a:spAutoFit/>
           </a:bodyPr>
           <a:lstStyle/>
@@ -15206,7 +14603,6 @@
           <a:lstStyle/>
           <a:p>
             <a:pPr algn="ctr"/>
-            <a:endParaRPr/>
           </a:p>
         </p:txBody>
       </p:sp>
@@ -15253,7 +14649,6 @@
           <a:lstStyle/>
           <a:p>
             <a:pPr algn="ctr"/>
-            <a:endParaRPr/>
           </a:p>
         </p:txBody>
       </p:sp>
@@ -15274,7 +14669,7 @@
           <a:noFill/>
         </p:spPr>
         <p:txBody>
-          <a:bodyPr wrap="square" lIns="0" tIns="0" rIns="0" bIns="0" anchor="ctr">
+          <a:bodyPr wrap="square" anchor="ctr" lIns="0" rIns="0" tIns="0" bIns="0">
             <a:spAutoFit/>
           </a:bodyPr>
           <a:lstStyle/>
@@ -15319,7 +14714,7 @@
           <a:noFill/>
         </p:spPr>
         <p:txBody>
-          <a:bodyPr wrap="square" lIns="0" tIns="0" rIns="0" bIns="0" anchor="t">
+          <a:bodyPr wrap="square" anchor="t" lIns="0" rIns="0" tIns="0" bIns="0">
             <a:spAutoFit/>
           </a:bodyPr>
           <a:lstStyle/>
@@ -15364,7 +14759,7 @@
           <a:noFill/>
         </p:spPr>
         <p:txBody>
-          <a:bodyPr wrap="square" lIns="0" tIns="0" rIns="0" bIns="0" anchor="t">
+          <a:bodyPr wrap="square" anchor="t" lIns="0" rIns="0" tIns="0" bIns="0">
             <a:spAutoFit/>
           </a:bodyPr>
           <a:lstStyle/>
@@ -15443,7 +14838,6 @@
           <a:lstStyle/>
           <a:p>
             <a:pPr algn="ctr"/>
-            <a:endParaRPr/>
           </a:p>
         </p:txBody>
       </p:sp>
@@ -15490,7 +14884,6 @@
           <a:lstStyle/>
           <a:p>
             <a:pPr algn="ctr"/>
-            <a:endParaRPr/>
           </a:p>
         </p:txBody>
       </p:sp>
@@ -15511,7 +14904,7 @@
           <a:noFill/>
         </p:spPr>
         <p:txBody>
-          <a:bodyPr wrap="square" lIns="0" tIns="0" rIns="0" bIns="0" anchor="ctr">
+          <a:bodyPr wrap="square" anchor="ctr" lIns="0" rIns="0" tIns="0" bIns="0">
             <a:spAutoFit/>
           </a:bodyPr>
           <a:lstStyle/>
@@ -15556,7 +14949,7 @@
           <a:noFill/>
         </p:spPr>
         <p:txBody>
-          <a:bodyPr wrap="square" lIns="0" tIns="0" rIns="0" bIns="0" anchor="t">
+          <a:bodyPr wrap="square" anchor="t" lIns="0" rIns="0" tIns="0" bIns="0">
             <a:spAutoFit/>
           </a:bodyPr>
           <a:lstStyle/>
@@ -15601,7 +14994,7 @@
           <a:noFill/>
         </p:spPr>
         <p:txBody>
-          <a:bodyPr wrap="square" lIns="0" tIns="0" rIns="0" bIns="0" anchor="t">
+          <a:bodyPr wrap="square" anchor="t" lIns="0" rIns="0" tIns="0" bIns="0">
             <a:spAutoFit/>
           </a:bodyPr>
           <a:lstStyle/>
@@ -15680,7 +15073,6 @@
           <a:lstStyle/>
           <a:p>
             <a:pPr algn="ctr"/>
-            <a:endParaRPr/>
           </a:p>
         </p:txBody>
       </p:sp>
@@ -15727,7 +15119,6 @@
           <a:lstStyle/>
           <a:p>
             <a:pPr algn="ctr"/>
-            <a:endParaRPr/>
           </a:p>
         </p:txBody>
       </p:sp>
@@ -15748,7 +15139,7 @@
           <a:noFill/>
         </p:spPr>
         <p:txBody>
-          <a:bodyPr wrap="square" lIns="0" tIns="0" rIns="0" bIns="0" anchor="ctr">
+          <a:bodyPr wrap="square" anchor="ctr" lIns="0" rIns="0" tIns="0" bIns="0">
             <a:spAutoFit/>
           </a:bodyPr>
           <a:lstStyle/>
@@ -15793,7 +15184,7 @@
           <a:noFill/>
         </p:spPr>
         <p:txBody>
-          <a:bodyPr wrap="square" lIns="0" tIns="0" rIns="0" bIns="0" anchor="t">
+          <a:bodyPr wrap="square" anchor="t" lIns="0" rIns="0" tIns="0" bIns="0">
             <a:spAutoFit/>
           </a:bodyPr>
           <a:lstStyle/>
@@ -15830,7 +15221,7 @@
         <p:spPr>
           <a:xfrm>
             <a:off x="1097280" y="4800599"/>
-            <a:ext cx="2743200" cy="649152"/>
+            <a:ext cx="2743200" cy="914400"/>
           </a:xfrm>
           <a:prstGeom prst="rect">
             <a:avLst/>
@@ -15838,7 +15229,7 @@
           <a:noFill/>
         </p:spPr>
         <p:txBody>
-          <a:bodyPr wrap="square" lIns="0" tIns="0" rIns="0" bIns="0" anchor="t">
+          <a:bodyPr wrap="square" anchor="t" lIns="0" rIns="0" tIns="0" bIns="0">
             <a:spAutoFit/>
           </a:bodyPr>
           <a:lstStyle/>
@@ -15855,157 +15246,13 @@
               </a:spcAft>
             </a:pPr>
             <a:r>
-              <a:rPr sz="1300" b="0" i="0" dirty="0" err="1">
+              <a:rPr sz="1300" b="0" i="0">
                 <a:solidFill>
                   <a:srgbClr val="5A6473"/>
                 </a:solidFill>
                 <a:latin typeface="Calibri"/>
               </a:rPr>
-              <a:t>Lokale</a:t>
-            </a:r>
-            <a:r>
-              <a:rPr sz="1300" b="0" i="0" dirty="0">
-                <a:solidFill>
-                  <a:srgbClr val="5A6473"/>
-                </a:solidFill>
-                <a:latin typeface="Calibri"/>
-              </a:rPr>
-              <a:t> </a:t>
-            </a:r>
-            <a:r>
-              <a:rPr sz="1300" b="0" i="0" dirty="0" err="1">
-                <a:solidFill>
-                  <a:srgbClr val="5A6473"/>
-                </a:solidFill>
-                <a:latin typeface="Calibri"/>
-              </a:rPr>
-              <a:t>Datenbank</a:t>
-            </a:r>
-            <a:r>
-              <a:rPr sz="1300" b="0" i="0" dirty="0">
-                <a:solidFill>
-                  <a:srgbClr val="5A6473"/>
-                </a:solidFill>
-                <a:latin typeface="Calibri"/>
-              </a:rPr>
-              <a:t> – </a:t>
-            </a:r>
-            <a:r>
-              <a:rPr lang="de-DE" sz="1300" b="0" i="0" dirty="0">
-                <a:solidFill>
-                  <a:srgbClr val="5A6473"/>
-                </a:solidFill>
-                <a:latin typeface="Calibri"/>
-              </a:rPr>
-              <a:t>noch </a:t>
-            </a:r>
-            <a:r>
-              <a:rPr sz="1300" b="0" i="0" dirty="0" err="1">
-                <a:solidFill>
-                  <a:srgbClr val="5A6473"/>
-                </a:solidFill>
-                <a:latin typeface="Calibri"/>
-              </a:rPr>
-              <a:t>keine</a:t>
-            </a:r>
-            <a:r>
-              <a:rPr sz="1300" b="0" i="0" dirty="0">
-                <a:solidFill>
-                  <a:srgbClr val="5A6473"/>
-                </a:solidFill>
-                <a:latin typeface="Calibri"/>
-              </a:rPr>
-              <a:t> Cloud, </a:t>
-            </a:r>
-            <a:r>
-              <a:rPr sz="1300" b="0" i="0" dirty="0" err="1">
-                <a:solidFill>
-                  <a:srgbClr val="5A6473"/>
-                </a:solidFill>
-                <a:latin typeface="Calibri"/>
-              </a:rPr>
-              <a:t>keine</a:t>
-            </a:r>
-            <a:r>
-              <a:rPr sz="1300" b="0" i="0" dirty="0">
-                <a:solidFill>
-                  <a:srgbClr val="5A6473"/>
-                </a:solidFill>
-                <a:latin typeface="Calibri"/>
-              </a:rPr>
-              <a:t> </a:t>
-            </a:r>
-            <a:r>
-              <a:rPr sz="1300" b="0" i="0" dirty="0" err="1">
-                <a:solidFill>
-                  <a:srgbClr val="5A6473"/>
-                </a:solidFill>
-                <a:latin typeface="Calibri"/>
-              </a:rPr>
-              <a:t>sensiblen</a:t>
-            </a:r>
-            <a:r>
-              <a:rPr sz="1300" b="0" i="0" dirty="0">
-                <a:solidFill>
-                  <a:srgbClr val="5A6473"/>
-                </a:solidFill>
-                <a:latin typeface="Calibri"/>
-              </a:rPr>
-              <a:t> </a:t>
-            </a:r>
-            <a:r>
-              <a:rPr sz="1300" b="0" i="0" dirty="0" err="1">
-                <a:solidFill>
-                  <a:srgbClr val="5A6473"/>
-                </a:solidFill>
-                <a:latin typeface="Calibri"/>
-              </a:rPr>
-              <a:t>Apotheken-Daten</a:t>
-            </a:r>
-            <a:r>
-              <a:rPr sz="1300" b="0" i="0" dirty="0">
-                <a:solidFill>
-                  <a:srgbClr val="5A6473"/>
-                </a:solidFill>
-                <a:latin typeface="Calibri"/>
-              </a:rPr>
-              <a:t> </a:t>
-            </a:r>
-            <a:r>
-              <a:rPr sz="1300" b="0" i="0" dirty="0" err="1">
-                <a:solidFill>
-                  <a:srgbClr val="5A6473"/>
-                </a:solidFill>
-                <a:latin typeface="Calibri"/>
-              </a:rPr>
-              <a:t>bei</a:t>
-            </a:r>
-            <a:r>
-              <a:rPr sz="1300" b="0" i="0" dirty="0">
-                <a:solidFill>
-                  <a:srgbClr val="5A6473"/>
-                </a:solidFill>
-                <a:latin typeface="Calibri"/>
-              </a:rPr>
-              <a:t> </a:t>
-            </a:r>
-            <a:r>
-              <a:rPr sz="1300" b="0" i="0" dirty="0" err="1">
-                <a:solidFill>
-                  <a:srgbClr val="5A6473"/>
-                </a:solidFill>
-                <a:latin typeface="Calibri"/>
-              </a:rPr>
-              <a:t>Dritten</a:t>
-            </a:r>
-            <a:r>
-              <a:rPr sz="1300" b="0" i="0" dirty="0">
-                <a:solidFill>
-                  <a:srgbClr val="5A6473"/>
-                </a:solidFill>
-                <a:latin typeface="Calibri"/>
-              </a:rPr>
-              <a:t>.</a:t>
+              <a:t>Lokale Datenbank – keine Cloud, keine sensiblen Apotheken-Daten bei Dritten.</a:t>
             </a:r>
           </a:p>
         </p:txBody>
@@ -16061,7 +15308,6 @@
           <a:lstStyle/>
           <a:p>
             <a:pPr algn="ctr"/>
-            <a:endParaRPr/>
           </a:p>
         </p:txBody>
       </p:sp>
@@ -16108,7 +15354,6 @@
           <a:lstStyle/>
           <a:p>
             <a:pPr algn="ctr"/>
-            <a:endParaRPr/>
           </a:p>
         </p:txBody>
       </p:sp>
@@ -16129,7 +15374,7 @@
           <a:noFill/>
         </p:spPr>
         <p:txBody>
-          <a:bodyPr wrap="square" lIns="0" tIns="0" rIns="0" bIns="0" anchor="ctr">
+          <a:bodyPr wrap="square" anchor="ctr" lIns="0" rIns="0" tIns="0" bIns="0">
             <a:spAutoFit/>
           </a:bodyPr>
           <a:lstStyle/>
@@ -16174,7 +15419,7 @@
           <a:noFill/>
         </p:spPr>
         <p:txBody>
-          <a:bodyPr wrap="square" lIns="0" tIns="0" rIns="0" bIns="0" anchor="t">
+          <a:bodyPr wrap="square" anchor="t" lIns="0" rIns="0" tIns="0" bIns="0">
             <a:spAutoFit/>
           </a:bodyPr>
           <a:lstStyle/>
@@ -16219,7 +15464,7 @@
           <a:noFill/>
         </p:spPr>
         <p:txBody>
-          <a:bodyPr wrap="square" lIns="0" tIns="0" rIns="0" bIns="0" anchor="t">
+          <a:bodyPr wrap="square" anchor="t" lIns="0" rIns="0" tIns="0" bIns="0">
             <a:spAutoFit/>
           </a:bodyPr>
           <a:lstStyle/>
@@ -16298,7 +15543,6 @@
           <a:lstStyle/>
           <a:p>
             <a:pPr algn="ctr"/>
-            <a:endParaRPr/>
           </a:p>
         </p:txBody>
       </p:sp>
@@ -16345,7 +15589,6 @@
           <a:lstStyle/>
           <a:p>
             <a:pPr algn="ctr"/>
-            <a:endParaRPr/>
           </a:p>
         </p:txBody>
       </p:sp>
@@ -16366,7 +15609,7 @@
           <a:noFill/>
         </p:spPr>
         <p:txBody>
-          <a:bodyPr wrap="square" lIns="0" tIns="0" rIns="0" bIns="0" anchor="ctr">
+          <a:bodyPr wrap="square" anchor="ctr" lIns="0" rIns="0" tIns="0" bIns="0">
             <a:spAutoFit/>
           </a:bodyPr>
           <a:lstStyle/>
@@ -16411,7 +15654,7 @@
           <a:noFill/>
         </p:spPr>
         <p:txBody>
-          <a:bodyPr wrap="square" lIns="0" tIns="0" rIns="0" bIns="0" anchor="t">
+          <a:bodyPr wrap="square" anchor="t" lIns="0" rIns="0" tIns="0" bIns="0">
             <a:spAutoFit/>
           </a:bodyPr>
           <a:lstStyle/>
@@ -16448,7 +15691,7 @@
         <p:spPr>
           <a:xfrm>
             <a:off x="8351215" y="4800599"/>
-            <a:ext cx="2743200" cy="429092"/>
+            <a:ext cx="2743200" cy="914400"/>
           </a:xfrm>
           <a:prstGeom prst="rect">
             <a:avLst/>
@@ -16456,7 +15699,7 @@
           <a:noFill/>
         </p:spPr>
         <p:txBody>
-          <a:bodyPr wrap="square" lIns="0" tIns="0" rIns="0" bIns="0" anchor="t">
+          <a:bodyPr wrap="square" anchor="t" lIns="0" rIns="0" tIns="0" bIns="0">
             <a:spAutoFit/>
           </a:bodyPr>
           <a:lstStyle/>
@@ -16473,112 +15716,13 @@
               </a:spcAft>
             </a:pPr>
             <a:r>
-              <a:rPr sz="1300" b="0" i="0" dirty="0" err="1">
+              <a:rPr sz="1300" b="0" i="0">
                 <a:solidFill>
                   <a:srgbClr val="5A6473"/>
                 </a:solidFill>
                 <a:latin typeface="Calibri"/>
               </a:rPr>
-              <a:t>Exakt</a:t>
-            </a:r>
-            <a:r>
-              <a:rPr sz="1300" b="0" i="0" dirty="0">
-                <a:solidFill>
-                  <a:srgbClr val="5A6473"/>
-                </a:solidFill>
-                <a:latin typeface="Calibri"/>
-              </a:rPr>
-              <a:t> auf </a:t>
-            </a:r>
-            <a:r>
-              <a:rPr lang="de-DE" sz="1300" dirty="0">
-                <a:solidFill>
-                  <a:srgbClr val="5A6473"/>
-                </a:solidFill>
-                <a:latin typeface="Calibri"/>
-              </a:rPr>
-              <a:t>Ihre</a:t>
-            </a:r>
-            <a:r>
-              <a:rPr sz="1300" b="0" i="0" dirty="0">
-                <a:solidFill>
-                  <a:srgbClr val="5A6473"/>
-                </a:solidFill>
-                <a:latin typeface="Calibri"/>
-              </a:rPr>
-              <a:t> </a:t>
-            </a:r>
-            <a:r>
-              <a:rPr sz="1300" b="0" i="0" dirty="0" err="1">
-                <a:solidFill>
-                  <a:srgbClr val="5A6473"/>
-                </a:solidFill>
-                <a:latin typeface="Calibri"/>
-              </a:rPr>
-              <a:t>Prozesse</a:t>
-            </a:r>
-            <a:r>
-              <a:rPr sz="1300" b="0" i="0" dirty="0">
-                <a:solidFill>
-                  <a:srgbClr val="5A6473"/>
-                </a:solidFill>
-                <a:latin typeface="Calibri"/>
-              </a:rPr>
-              <a:t> </a:t>
-            </a:r>
-            <a:r>
-              <a:rPr sz="1300" b="0" i="0" dirty="0" err="1">
-                <a:solidFill>
-                  <a:srgbClr val="5A6473"/>
-                </a:solidFill>
-                <a:latin typeface="Calibri"/>
-              </a:rPr>
-              <a:t>zugeschnitten</a:t>
-            </a:r>
-            <a:r>
-              <a:rPr sz="1300" b="0" i="0" dirty="0">
-                <a:solidFill>
-                  <a:srgbClr val="5A6473"/>
-                </a:solidFill>
-                <a:latin typeface="Calibri"/>
-              </a:rPr>
-              <a:t> und </a:t>
-            </a:r>
-            <a:r>
-              <a:rPr sz="1300" b="0" i="0" dirty="0" err="1">
-                <a:solidFill>
-                  <a:srgbClr val="5A6473"/>
-                </a:solidFill>
-                <a:latin typeface="Calibri"/>
-              </a:rPr>
-              <a:t>jederzeit</a:t>
-            </a:r>
-            <a:r>
-              <a:rPr sz="1300" b="0" i="0" dirty="0">
-                <a:solidFill>
-                  <a:srgbClr val="5A6473"/>
-                </a:solidFill>
-                <a:latin typeface="Calibri"/>
-              </a:rPr>
-              <a:t> </a:t>
-            </a:r>
-            <a:r>
-              <a:rPr sz="1300" b="0" i="0" dirty="0" err="1">
-                <a:solidFill>
-                  <a:srgbClr val="5A6473"/>
-                </a:solidFill>
-                <a:latin typeface="Calibri"/>
-              </a:rPr>
-              <a:t>erweiterbar</a:t>
-            </a:r>
-            <a:r>
-              <a:rPr sz="1300" b="0" i="0" dirty="0">
-                <a:solidFill>
-                  <a:srgbClr val="5A6473"/>
-                </a:solidFill>
-                <a:latin typeface="Calibri"/>
-              </a:rPr>
-              <a:t>.</a:t>
+              <a:t>Exakt auf unsere Prozesse zugeschnitten und jederzeit erweiterbar.</a:t>
             </a:r>
           </a:p>
         </p:txBody>
@@ -16600,7 +15744,7 @@
           <a:noFill/>
         </p:spPr>
         <p:txBody>
-          <a:bodyPr wrap="square" lIns="0" tIns="0" rIns="0" bIns="0" anchor="t">
+          <a:bodyPr wrap="square" anchor="t" lIns="0" rIns="0" tIns="0" bIns="0">
             <a:spAutoFit/>
           </a:bodyPr>
           <a:lstStyle/>
@@ -16637,7 +15781,7 @@
 </file>
 
 <file path=ppt/slides/slide9.xml><?xml version="1.0" encoding="utf-8"?>
-<p:sld xmlns:a="http://schemas.openxmlformats.org/drawingml/2006/main" xmlns:r="http://schemas.openxmlformats.org/officeDocument/2006/relationships" xmlns:p="http://schemas.openxmlformats.org/presentationml/2006/main">
+<p:sld xmlns:a="http://schemas.openxmlformats.org/drawingml/2006/main" xmlns:p="http://schemas.openxmlformats.org/presentationml/2006/main" xmlns:r="http://schemas.openxmlformats.org/officeDocument/2006/relationships">
   <p:cSld>
     <p:bg>
       <p:bgPr>
@@ -16653,14 +15797,7 @@
         <p:cNvGrpSpPr/>
         <p:nvPr/>
       </p:nvGrpSpPr>
-      <p:grpSpPr>
-        <a:xfrm>
-          <a:off x="0" y="0"/>
-          <a:ext cx="0" cy="0"/>
-          <a:chOff x="0" y="0"/>
-          <a:chExt cx="0" cy="0"/>
-        </a:xfrm>
-      </p:grpSpPr>
+      <p:grpSpPr/>
       <p:sp>
         <p:nvSpPr>
           <p:cNvPr id="2" name="TextBox 1"/>
@@ -16678,7 +15815,7 @@
           <a:noFill/>
         </p:spPr>
         <p:txBody>
-          <a:bodyPr wrap="square" lIns="0" tIns="0" rIns="0" bIns="0" anchor="t">
+          <a:bodyPr wrap="square" anchor="t" lIns="0" rIns="0" tIns="0" bIns="0">
             <a:spAutoFit/>
           </a:bodyPr>
           <a:lstStyle/>
@@ -16757,7 +15894,6 @@
           <a:lstStyle/>
           <a:p>
             <a:pPr algn="ctr"/>
-            <a:endParaRPr/>
           </a:p>
         </p:txBody>
       </p:sp>
@@ -16802,7 +15938,6 @@
           <a:lstStyle/>
           <a:p>
             <a:pPr algn="ctr"/>
-            <a:endParaRPr/>
           </a:p>
         </p:txBody>
       </p:sp>
@@ -16823,7 +15958,7 @@
           <a:noFill/>
         </p:spPr>
         <p:txBody>
-          <a:bodyPr wrap="square" lIns="0" tIns="0" rIns="0" bIns="0" anchor="t">
+          <a:bodyPr wrap="square" anchor="t" lIns="0" rIns="0" tIns="0" bIns="0">
             <a:spAutoFit/>
           </a:bodyPr>
           <a:lstStyle/>
@@ -16860,7 +15995,7 @@
         <p:spPr>
           <a:xfrm>
             <a:off x="1234440" y="2313432"/>
-            <a:ext cx="4572000" cy="395814"/>
+            <a:ext cx="4572000" cy="548640"/>
           </a:xfrm>
           <a:prstGeom prst="rect">
             <a:avLst/>
@@ -16868,7 +16003,7 @@
           <a:noFill/>
         </p:spPr>
         <p:txBody>
-          <a:bodyPr wrap="square" lIns="0" tIns="0" rIns="0" bIns="0" anchor="t">
+          <a:bodyPr wrap="square" anchor="t" lIns="0" rIns="0" tIns="0" bIns="0">
             <a:spAutoFit/>
           </a:bodyPr>
           <a:lstStyle/>
@@ -16885,103 +16020,13 @@
               </a:spcAft>
             </a:pPr>
             <a:r>
-              <a:rPr sz="1250" b="0" i="0" dirty="0" err="1">
+              <a:rPr sz="1250" b="0" i="0">
                 <a:solidFill>
                   <a:srgbClr val="5A6473"/>
                 </a:solidFill>
                 <a:latin typeface="Calibri"/>
               </a:rPr>
-              <a:t>Läuft</a:t>
-            </a:r>
-            <a:r>
-              <a:rPr sz="1250" b="0" i="0" dirty="0">
-                <a:solidFill>
-                  <a:srgbClr val="5A6473"/>
-                </a:solidFill>
-                <a:latin typeface="Calibri"/>
-              </a:rPr>
-              <a:t> </a:t>
-            </a:r>
-            <a:r>
-              <a:rPr sz="1250" b="0" i="0" dirty="0" err="1">
-                <a:solidFill>
-                  <a:srgbClr val="5A6473"/>
-                </a:solidFill>
-                <a:latin typeface="Calibri"/>
-              </a:rPr>
-              <a:t>lokal</a:t>
-            </a:r>
-            <a:r>
-              <a:rPr sz="1250" b="0" i="0" dirty="0">
-                <a:solidFill>
-                  <a:srgbClr val="5A6473"/>
-                </a:solidFill>
-                <a:latin typeface="Calibri"/>
-              </a:rPr>
-              <a:t> auf den </a:t>
-            </a:r>
-            <a:r>
-              <a:rPr sz="1250" b="0" i="0" dirty="0" err="1">
-                <a:solidFill>
-                  <a:srgbClr val="5A6473"/>
-                </a:solidFill>
-                <a:latin typeface="Calibri"/>
-              </a:rPr>
-              <a:t>Arbeitsplätzen</a:t>
-            </a:r>
-            <a:r>
-              <a:rPr sz="1250" b="0" i="0" dirty="0">
-                <a:solidFill>
-                  <a:srgbClr val="5A6473"/>
-                </a:solidFill>
-                <a:latin typeface="Calibri"/>
-              </a:rPr>
-              <a:t>, Installation per Setup – </a:t>
-            </a:r>
-            <a:r>
-              <a:rPr lang="de-DE" sz="1250" b="0" i="0" dirty="0">
-                <a:solidFill>
-                  <a:srgbClr val="5A6473"/>
-                </a:solidFill>
-                <a:latin typeface="Calibri"/>
-              </a:rPr>
-              <a:t>noch </a:t>
-            </a:r>
-            <a:r>
-              <a:rPr sz="1250" b="0" i="0" dirty="0" err="1">
-                <a:solidFill>
-                  <a:srgbClr val="5A6473"/>
-                </a:solidFill>
-                <a:latin typeface="Calibri"/>
-              </a:rPr>
-              <a:t>kein</a:t>
-            </a:r>
-            <a:r>
-              <a:rPr sz="1250" b="0" i="0" dirty="0">
-                <a:solidFill>
-                  <a:srgbClr val="5A6473"/>
-                </a:solidFill>
-                <a:latin typeface="Calibri"/>
-              </a:rPr>
-              <a:t> Server </a:t>
-            </a:r>
-            <a:r>
-              <a:rPr sz="1250" b="0" i="0" dirty="0" err="1">
-                <a:solidFill>
-                  <a:srgbClr val="5A6473"/>
-                </a:solidFill>
-                <a:latin typeface="Calibri"/>
-              </a:rPr>
-              <a:t>nötig</a:t>
-            </a:r>
-            <a:r>
-              <a:rPr sz="1250" b="0" i="0" dirty="0">
-                <a:solidFill>
-                  <a:srgbClr val="5A6473"/>
-                </a:solidFill>
-                <a:latin typeface="Calibri"/>
-              </a:rPr>
-              <a:t>.</a:t>
+              <a:t>Läuft lokal auf den Arbeitsplätzen, Installation per Setup – kein Server nötig.</a:t>
             </a:r>
           </a:p>
         </p:txBody>
@@ -17037,7 +16082,6 @@
           <a:lstStyle/>
           <a:p>
             <a:pPr algn="ctr"/>
-            <a:endParaRPr/>
           </a:p>
         </p:txBody>
       </p:sp>
@@ -17082,7 +16126,6 @@
           <a:lstStyle/>
           <a:p>
             <a:pPr algn="ctr"/>
-            <a:endParaRPr/>
           </a:p>
         </p:txBody>
       </p:sp>
@@ -17103,7 +16146,7 @@
           <a:noFill/>
         </p:spPr>
         <p:txBody>
-          <a:bodyPr wrap="square" lIns="0" tIns="0" rIns="0" bIns="0" anchor="t">
+          <a:bodyPr wrap="square" anchor="t" lIns="0" rIns="0" tIns="0" bIns="0">
             <a:spAutoFit/>
           </a:bodyPr>
           <a:lstStyle/>
@@ -17148,7 +16191,7 @@
           <a:noFill/>
         </p:spPr>
         <p:txBody>
-          <a:bodyPr wrap="square" lIns="0" tIns="0" rIns="0" bIns="0" anchor="t">
+          <a:bodyPr wrap="square" anchor="t" lIns="0" rIns="0" tIns="0" bIns="0">
             <a:spAutoFit/>
           </a:bodyPr>
           <a:lstStyle/>
@@ -17227,7 +16270,6 @@
           <a:lstStyle/>
           <a:p>
             <a:pPr algn="ctr"/>
-            <a:endParaRPr/>
           </a:p>
         </p:txBody>
       </p:sp>
@@ -17272,7 +16314,6 @@
           <a:lstStyle/>
           <a:p>
             <a:pPr algn="ctr"/>
-            <a:endParaRPr/>
           </a:p>
         </p:txBody>
       </p:sp>
@@ -17293,7 +16334,7 @@
           <a:noFill/>
         </p:spPr>
         <p:txBody>
-          <a:bodyPr wrap="square" lIns="0" tIns="0" rIns="0" bIns="0" anchor="t">
+          <a:bodyPr wrap="square" anchor="t" lIns="0" rIns="0" tIns="0" bIns="0">
             <a:spAutoFit/>
           </a:bodyPr>
           <a:lstStyle/>
@@ -17338,7 +16379,7 @@
           <a:noFill/>
         </p:spPr>
         <p:txBody>
-          <a:bodyPr wrap="square" lIns="0" tIns="0" rIns="0" bIns="0" anchor="t">
+          <a:bodyPr wrap="square" anchor="t" lIns="0" rIns="0" tIns="0" bIns="0">
             <a:spAutoFit/>
           </a:bodyPr>
           <a:lstStyle/>
@@ -17417,7 +16458,6 @@
           <a:lstStyle/>
           <a:p>
             <a:pPr algn="ctr"/>
-            <a:endParaRPr/>
           </a:p>
         </p:txBody>
       </p:sp>
@@ -17462,7 +16502,6 @@
           <a:lstStyle/>
           <a:p>
             <a:pPr algn="ctr"/>
-            <a:endParaRPr/>
           </a:p>
         </p:txBody>
       </p:sp>
@@ -17483,7 +16522,7 @@
           <a:noFill/>
         </p:spPr>
         <p:txBody>
-          <a:bodyPr wrap="square" lIns="0" tIns="0" rIns="0" bIns="0" anchor="t">
+          <a:bodyPr wrap="square" anchor="t" lIns="0" rIns="0" tIns="0" bIns="0">
             <a:spAutoFit/>
           </a:bodyPr>
           <a:lstStyle/>
@@ -17528,7 +16567,7 @@
           <a:noFill/>
         </p:spPr>
         <p:txBody>
-          <a:bodyPr wrap="square" lIns="0" tIns="0" rIns="0" bIns="0" anchor="t">
+          <a:bodyPr wrap="square" anchor="t" lIns="0" rIns="0" tIns="0" bIns="0">
             <a:spAutoFit/>
           </a:bodyPr>
           <a:lstStyle/>
@@ -17607,7 +16646,6 @@
           <a:lstStyle/>
           <a:p>
             <a:pPr algn="ctr"/>
-            <a:endParaRPr/>
           </a:p>
         </p:txBody>
       </p:sp>
@@ -17652,7 +16690,6 @@
           <a:lstStyle/>
           <a:p>
             <a:pPr algn="ctr"/>
-            <a:endParaRPr/>
           </a:p>
         </p:txBody>
       </p:sp>
@@ -17673,7 +16710,7 @@
           <a:noFill/>
         </p:spPr>
         <p:txBody>
-          <a:bodyPr wrap="square" lIns="0" tIns="0" rIns="0" bIns="0" anchor="t">
+          <a:bodyPr wrap="square" anchor="t" lIns="0" rIns="0" tIns="0" bIns="0">
             <a:spAutoFit/>
           </a:bodyPr>
           <a:lstStyle/>
@@ -17718,7 +16755,7 @@
           <a:noFill/>
         </p:spPr>
         <p:txBody>
-          <a:bodyPr wrap="square" lIns="0" tIns="0" rIns="0" bIns="0" anchor="t">
+          <a:bodyPr wrap="square" anchor="t" lIns="0" rIns="0" tIns="0" bIns="0">
             <a:spAutoFit/>
           </a:bodyPr>
           <a:lstStyle/>
@@ -17797,7 +16834,6 @@
           <a:lstStyle/>
           <a:p>
             <a:pPr algn="ctr"/>
-            <a:endParaRPr/>
           </a:p>
         </p:txBody>
       </p:sp>
@@ -17842,7 +16878,6 @@
           <a:lstStyle/>
           <a:p>
             <a:pPr algn="ctr"/>
-            <a:endParaRPr/>
           </a:p>
         </p:txBody>
       </p:sp>
@@ -17863,7 +16898,7 @@
           <a:noFill/>
         </p:spPr>
         <p:txBody>
-          <a:bodyPr wrap="square" lIns="0" tIns="0" rIns="0" bIns="0" anchor="t">
+          <a:bodyPr wrap="square" anchor="t" lIns="0" rIns="0" tIns="0" bIns="0">
             <a:spAutoFit/>
           </a:bodyPr>
           <a:lstStyle/>
@@ -17908,7 +16943,7 @@
           <a:noFill/>
         </p:spPr>
         <p:txBody>
-          <a:bodyPr wrap="square" lIns="0" tIns="0" rIns="0" bIns="0" anchor="t">
+          <a:bodyPr wrap="square" anchor="t" lIns="0" rIns="0" tIns="0" bIns="0">
             <a:spAutoFit/>
           </a:bodyPr>
           <a:lstStyle/>
@@ -17953,7 +16988,7 @@
           <a:noFill/>
         </p:spPr>
         <p:txBody>
-          <a:bodyPr wrap="square" lIns="0" tIns="0" rIns="0" bIns="0" anchor="t">
+          <a:bodyPr wrap="square" anchor="t" lIns="0" rIns="0" tIns="0" bIns="0">
             <a:spAutoFit/>
           </a:bodyPr>
           <a:lstStyle/>

</xml_diff>